<commit_message>
last minute change for presentations slides
</commit_message>
<xml_diff>
--- a/2. Projects/5. Final Submission/HWE_Vending Machine Presentations_Summer 2025.pptx
+++ b/2. Projects/5. Final Submission/HWE_Vending Machine Presentations_Summer 2025.pptx
@@ -8460,6 +8460,10 @@
           </p:nvPr>
         </p:nvSpPr>
         <p:spPr>
+          <a:xfrm>
+            <a:off x="311700" y="333981"/>
+            <a:ext cx="8520600" cy="572700"/>
+          </a:xfrm>
           <a:prstGeom prst="rect">
             <a:avLst/>
           </a:prstGeom>
@@ -8480,10 +8484,14 @@
               <a:buNone/>
             </a:pPr>
             <a:r>
-              <a:rPr lang="en-GB"/>
-              <a:t>Verification with Test Benches_Results:FSM_Controller</a:t>
-            </a:r>
-            <a:endParaRPr/>
+              <a:rPr lang="en-GB" dirty="0"/>
+              <a:t>Test </a:t>
+            </a:r>
+            <a:r>
+              <a:rPr lang="en-GB" dirty="0" err="1"/>
+              <a:t>Benches_Results:FSM_Controller</a:t>
+            </a:r>
+            <a:endParaRPr dirty="0"/>
           </a:p>
         </p:txBody>
       </p:sp>
@@ -9230,6 +9238,10 @@
           </p:nvPr>
         </p:nvSpPr>
         <p:spPr>
+          <a:xfrm>
+            <a:off x="311700" y="384550"/>
+            <a:ext cx="8520600" cy="572700"/>
+          </a:xfrm>
           <a:prstGeom prst="rect">
             <a:avLst/>
           </a:prstGeom>
@@ -9250,10 +9262,14 @@
               <a:buNone/>
             </a:pPr>
             <a:r>
-              <a:rPr lang="en-GB"/>
-              <a:t>Verification with Test Benches_Results:Coin_Handler</a:t>
-            </a:r>
-            <a:endParaRPr/>
+              <a:rPr lang="en-GB" dirty="0"/>
+              <a:t>Test </a:t>
+            </a:r>
+            <a:r>
+              <a:rPr lang="en-GB" dirty="0" err="1"/>
+              <a:t>Benches_Results:Coin_Handler</a:t>
+            </a:r>
+            <a:endParaRPr dirty="0"/>
           </a:p>
         </p:txBody>
       </p:sp>
@@ -9921,6 +9937,10 @@
           </p:nvPr>
         </p:nvSpPr>
         <p:spPr>
+          <a:xfrm>
+            <a:off x="311700" y="425513"/>
+            <a:ext cx="8520600" cy="572700"/>
+          </a:xfrm>
           <a:prstGeom prst="rect">
             <a:avLst/>
           </a:prstGeom>
@@ -9941,10 +9961,14 @@
               <a:buNone/>
             </a:pPr>
             <a:r>
-              <a:rPr lang="en-GB"/>
-              <a:t>Verification with Test Benches_Results:Display_Manager</a:t>
-            </a:r>
-            <a:endParaRPr/>
+              <a:rPr lang="en-GB" dirty="0"/>
+              <a:t>Test </a:t>
+            </a:r>
+            <a:r>
+              <a:rPr lang="en-GB" dirty="0" err="1"/>
+              <a:t>Benches_Results:Display_Manager</a:t>
+            </a:r>
+            <a:endParaRPr dirty="0"/>
           </a:p>
         </p:txBody>
       </p:sp>
@@ -11368,7 +11392,7 @@
         <p:spPr>
           <a:xfrm>
             <a:off x="311699" y="1152475"/>
-            <a:ext cx="2998829" cy="3459600"/>
+            <a:ext cx="3600061" cy="3459600"/>
           </a:xfrm>
           <a:prstGeom prst="rect">
             <a:avLst/>
@@ -11405,6 +11429,9 @@
           </a:p>
           <a:p>
             <a:pPr marL="457200" lvl="0" indent="-298450" algn="l" rtl="0">
+              <a:lnSpc>
+                <a:spcPct val="100000"/>
+              </a:lnSpc>
               <a:spcBef>
                 <a:spcPts val="1200"/>
               </a:spcBef>
@@ -11423,7 +11450,7 @@
                   <a:schemeClr val="dk1"/>
                 </a:solidFill>
               </a:rPr>
-              <a:t>Two 7 segment display </a:t>
+              <a:t>Two 7 segment display</a:t>
             </a:r>
             <a:endParaRPr sz="1100" dirty="0">
               <a:solidFill>
@@ -12520,7 +12547,7 @@
         <p:spPr>
           <a:xfrm>
             <a:off x="311700" y="1282075"/>
-            <a:ext cx="8520600" cy="3416400"/>
+            <a:ext cx="5481725" cy="3416400"/>
           </a:xfrm>
           <a:prstGeom prst="rect">
             <a:avLst/>
@@ -12879,6 +12906,88 @@
                 <a:schemeClr val="dk2"/>
               </a:solidFill>
             </a:endParaRPr>
+          </a:p>
+        </p:txBody>
+      </p:sp>
+      <p:pic>
+        <p:nvPicPr>
+          <p:cNvPr id="1026" name="Picture 2" descr="https://lh7-rt.googleusercontent.com/slidesz/AGV_vUf_K22Ka0hcfuUDwdES_n5GY5aj7ju9OFzCBPf17Xed2GB5UFDUnviy2Hc-nhM_7sLFejdh9yGkLn6mN-A_bOvSz2CnA3x8kMAKPxpigVh3LO4p5fx0vFOTPmlGVwivkXilAS3bhQ=s2048?key=lRNno0ZX1l3jrIPIVq1ymw">
+            <a:extLst>
+              <a:ext uri="{FF2B5EF4-FFF2-40B4-BE49-F238E27FC236}">
+                <a16:creationId xmlns:a16="http://schemas.microsoft.com/office/drawing/2014/main" id="{8C71DDF5-9C1A-4AC4-8D81-9D2C2FE50F26}"/>
+              </a:ext>
+            </a:extLst>
+          </p:cNvPr>
+          <p:cNvPicPr>
+            <a:picLocks noChangeAspect="1" noChangeArrowheads="1"/>
+          </p:cNvPicPr>
+          <p:nvPr/>
+        </p:nvPicPr>
+        <p:blipFill>
+          <a:blip r:embed="rId3">
+            <a:extLst>
+              <a:ext uri="{28A0092B-C50C-407E-A947-70E740481C1C}">
+                <a14:useLocalDpi xmlns:a14="http://schemas.microsoft.com/office/drawing/2010/main" val="0"/>
+              </a:ext>
+            </a:extLst>
+          </a:blip>
+          <a:srcRect/>
+          <a:stretch>
+            <a:fillRect/>
+          </a:stretch>
+        </p:blipFill>
+        <p:spPr bwMode="auto">
+          <a:xfrm>
+            <a:off x="5993113" y="1103150"/>
+            <a:ext cx="3052731" cy="3301351"/>
+          </a:xfrm>
+          <a:prstGeom prst="rect">
+            <a:avLst/>
+          </a:prstGeom>
+          <a:noFill/>
+          <a:extLst>
+            <a:ext uri="{909E8E84-426E-40DD-AFC4-6F175D3DCCD1}">
+              <a14:hiddenFill xmlns:a14="http://schemas.microsoft.com/office/drawing/2010/main">
+                <a:solidFill>
+                  <a:srgbClr val="FFFFFF"/>
+                </a:solidFill>
+              </a14:hiddenFill>
+            </a:ext>
+          </a:extLst>
+        </p:spPr>
+      </p:pic>
+      <p:sp>
+        <p:nvSpPr>
+          <p:cNvPr id="2" name="Rectangle 1">
+            <a:extLst>
+              <a:ext uri="{FF2B5EF4-FFF2-40B4-BE49-F238E27FC236}">
+                <a16:creationId xmlns:a16="http://schemas.microsoft.com/office/drawing/2014/main" id="{567A0067-09E1-43BA-9D34-2D2D9BA676E7}"/>
+              </a:ext>
+            </a:extLst>
+          </p:cNvPr>
+          <p:cNvSpPr/>
+          <p:nvPr/>
+        </p:nvSpPr>
+        <p:spPr>
+          <a:xfrm>
+            <a:off x="5896870" y="4415735"/>
+            <a:ext cx="1725355" cy="323165"/>
+          </a:xfrm>
+          <a:prstGeom prst="rect">
+            <a:avLst/>
+          </a:prstGeom>
+        </p:spPr>
+        <p:txBody>
+          <a:bodyPr wrap="square">
+            <a:spAutoFit/>
+          </a:bodyPr>
+          <a:lstStyle/>
+          <a:p>
+            <a:r>
+              <a:rPr lang="en-US" sz="1500" dirty="0"/>
+              <a:t>Fig: PCB Layout</a:t>
+            </a:r>
+            <a:endParaRPr lang="en-US" dirty="0"/>
           </a:p>
         </p:txBody>
       </p:sp>
@@ -13551,6 +13660,53 @@
           </a:p>
         </p:txBody>
       </p:sp>
+      <p:pic>
+        <p:nvPicPr>
+          <p:cNvPr id="2050" name="Picture 2" descr="https://lh7-rt.googleusercontent.com/slidesz/AGV_vUexE-Gv7nZ_QFGUqZv3ujHZEA437Ha_jnvLhujoHFedXPFYPJpb2r96jCS2_8MosMGNfhdAsxnFC5CcUYHLtIdLx2vZ-KdF6K0MFBUVGOBW-W9_yrae4GI0SS_f_9pGl17KdRUi=s2048?key=lRNno0ZX1l3jrIPIVq1ymw">
+            <a:extLst>
+              <a:ext uri="{FF2B5EF4-FFF2-40B4-BE49-F238E27FC236}">
+                <a16:creationId xmlns:a16="http://schemas.microsoft.com/office/drawing/2014/main" id="{95047251-BD72-4365-97EF-EC10A2B0F2C6}"/>
+              </a:ext>
+            </a:extLst>
+          </p:cNvPr>
+          <p:cNvPicPr>
+            <a:picLocks noChangeAspect="1" noChangeArrowheads="1"/>
+          </p:cNvPicPr>
+          <p:nvPr/>
+        </p:nvPicPr>
+        <p:blipFill>
+          <a:blip r:embed="rId7">
+            <a:extLst>
+              <a:ext uri="{28A0092B-C50C-407E-A947-70E740481C1C}">
+                <a14:useLocalDpi xmlns:a14="http://schemas.microsoft.com/office/drawing/2010/main" val="0"/>
+              </a:ext>
+            </a:extLst>
+          </a:blip>
+          <a:srcRect/>
+          <a:stretch>
+            <a:fillRect/>
+          </a:stretch>
+        </p:blipFill>
+        <p:spPr bwMode="auto">
+          <a:xfrm>
+            <a:off x="4705267" y="3114968"/>
+            <a:ext cx="2148823" cy="693169"/>
+          </a:xfrm>
+          <a:prstGeom prst="rect">
+            <a:avLst/>
+          </a:prstGeom>
+          <a:noFill/>
+          <a:extLst>
+            <a:ext uri="{909E8E84-426E-40DD-AFC4-6F175D3DCCD1}">
+              <a14:hiddenFill xmlns:a14="http://schemas.microsoft.com/office/drawing/2010/main">
+                <a:solidFill>
+                  <a:srgbClr val="FFFFFF"/>
+                </a:solidFill>
+              </a14:hiddenFill>
+            </a:ext>
+          </a:extLst>
+        </p:spPr>
+      </p:pic>
     </p:spTree>
   </p:cSld>
   <p:clrMapOvr>

</xml_diff>

<commit_message>
update before the presentation
</commit_message>
<xml_diff>
--- a/2. Projects/5. Final Submission/HWE_Vending Machine Presentations_Summer 2025.pptx
+++ b/2. Projects/5. Final Submission/HWE_Vending Machine Presentations_Summer 2025.pptx
@@ -5,31 +5,32 @@
     <p:sldMasterId id="2147483705" r:id="rId1"/>
   </p:sldMasterIdLst>
   <p:notesMasterIdLst>
-    <p:notesMasterId r:id="rId24"/>
+    <p:notesMasterId r:id="rId25"/>
   </p:notesMasterIdLst>
   <p:sldIdLst>
     <p:sldId id="256" r:id="rId2"/>
     <p:sldId id="257" r:id="rId3"/>
-    <p:sldId id="258" r:id="rId4"/>
-    <p:sldId id="259" r:id="rId5"/>
-    <p:sldId id="260" r:id="rId6"/>
-    <p:sldId id="261" r:id="rId7"/>
-    <p:sldId id="262" r:id="rId8"/>
-    <p:sldId id="263" r:id="rId9"/>
-    <p:sldId id="264" r:id="rId10"/>
-    <p:sldId id="265" r:id="rId11"/>
-    <p:sldId id="266" r:id="rId12"/>
-    <p:sldId id="267" r:id="rId13"/>
-    <p:sldId id="268" r:id="rId14"/>
-    <p:sldId id="269" r:id="rId15"/>
-    <p:sldId id="270" r:id="rId16"/>
-    <p:sldId id="271" r:id="rId17"/>
-    <p:sldId id="272" r:id="rId18"/>
-    <p:sldId id="273" r:id="rId19"/>
-    <p:sldId id="274" r:id="rId20"/>
-    <p:sldId id="275" r:id="rId21"/>
-    <p:sldId id="276" r:id="rId22"/>
-    <p:sldId id="277" r:id="rId23"/>
+    <p:sldId id="278" r:id="rId4"/>
+    <p:sldId id="258" r:id="rId5"/>
+    <p:sldId id="259" r:id="rId6"/>
+    <p:sldId id="260" r:id="rId7"/>
+    <p:sldId id="261" r:id="rId8"/>
+    <p:sldId id="262" r:id="rId9"/>
+    <p:sldId id="263" r:id="rId10"/>
+    <p:sldId id="264" r:id="rId11"/>
+    <p:sldId id="265" r:id="rId12"/>
+    <p:sldId id="266" r:id="rId13"/>
+    <p:sldId id="267" r:id="rId14"/>
+    <p:sldId id="268" r:id="rId15"/>
+    <p:sldId id="269" r:id="rId16"/>
+    <p:sldId id="270" r:id="rId17"/>
+    <p:sldId id="271" r:id="rId18"/>
+    <p:sldId id="272" r:id="rId19"/>
+    <p:sldId id="273" r:id="rId20"/>
+    <p:sldId id="274" r:id="rId21"/>
+    <p:sldId id="275" r:id="rId22"/>
+    <p:sldId id="276" r:id="rId23"/>
+    <p:sldId id="277" r:id="rId24"/>
   </p:sldIdLst>
   <p:sldSz cx="9144000" cy="5143500" type="screen16x9"/>
   <p:notesSz cx="6858000" cy="9144000"/>
@@ -697,7 +698,7 @@
   <p:cSld>
     <p:spTree>
       <p:nvGrpSpPr>
-        <p:cNvPr id="1" name="Shape 141"/>
+        <p:cNvPr id="1" name="Shape 131"/>
         <p:cNvGrpSpPr/>
         <p:nvPr/>
       </p:nvGrpSpPr>
@@ -711,7 +712,7 @@
       </p:grpSpPr>
       <p:sp>
         <p:nvSpPr>
-          <p:cNvPr id="142" name="Google Shape;142;g33d320e3551_0_11:notes"/>
+          <p:cNvPr id="132" name="Google Shape;132;g33d320e3551_0_360:notes"/>
           <p:cNvSpPr>
             <a:spLocks noGrp="1" noRot="1" noChangeAspect="1"/>
           </p:cNvSpPr>
@@ -752,7 +753,7 @@
       </p:sp>
       <p:sp>
         <p:nvSpPr>
-          <p:cNvPr id="143" name="Google Shape;143;g33d320e3551_0_11:notes"/>
+          <p:cNvPr id="133" name="Google Shape;133;g33d320e3551_0_360:notes"/>
           <p:cNvSpPr txBox="1">
             <a:spLocks noGrp="1"/>
           </p:cNvSpPr>
@@ -801,7 +802,7 @@
   <p:cSld>
     <p:spTree>
       <p:nvGrpSpPr>
-        <p:cNvPr id="1" name="Shape 150"/>
+        <p:cNvPr id="1" name="Shape 141"/>
         <p:cNvGrpSpPr/>
         <p:nvPr/>
       </p:nvGrpSpPr>
@@ -815,7 +816,7 @@
       </p:grpSpPr>
       <p:sp>
         <p:nvSpPr>
-          <p:cNvPr id="151" name="Google Shape;151;g33d320e3551_0_389:notes"/>
+          <p:cNvPr id="142" name="Google Shape;142;g33d320e3551_0_11:notes"/>
           <p:cNvSpPr>
             <a:spLocks noGrp="1" noRot="1" noChangeAspect="1"/>
           </p:cNvSpPr>
@@ -856,7 +857,7 @@
       </p:sp>
       <p:sp>
         <p:nvSpPr>
-          <p:cNvPr id="152" name="Google Shape;152;g33d320e3551_0_389:notes"/>
+          <p:cNvPr id="143" name="Google Shape;143;g33d320e3551_0_11:notes"/>
           <p:cNvSpPr txBox="1">
             <a:spLocks noGrp="1"/>
           </p:cNvSpPr>
@@ -905,7 +906,7 @@
   <p:cSld>
     <p:spTree>
       <p:nvGrpSpPr>
-        <p:cNvPr id="1" name="Shape 160"/>
+        <p:cNvPr id="1" name="Shape 150"/>
         <p:cNvGrpSpPr/>
         <p:nvPr/>
       </p:nvGrpSpPr>
@@ -919,7 +920,7 @@
       </p:grpSpPr>
       <p:sp>
         <p:nvSpPr>
-          <p:cNvPr id="161" name="Google Shape;161;g33d320e3551_0_369:notes"/>
+          <p:cNvPr id="151" name="Google Shape;151;g33d320e3551_0_389:notes"/>
           <p:cNvSpPr>
             <a:spLocks noGrp="1" noRot="1" noChangeAspect="1"/>
           </p:cNvSpPr>
@@ -960,7 +961,7 @@
       </p:sp>
       <p:sp>
         <p:nvSpPr>
-          <p:cNvPr id="162" name="Google Shape;162;g33d320e3551_0_369:notes"/>
+          <p:cNvPr id="152" name="Google Shape;152;g33d320e3551_0_389:notes"/>
           <p:cNvSpPr txBox="1">
             <a:spLocks noGrp="1"/>
           </p:cNvSpPr>
@@ -1009,7 +1010,7 @@
   <p:cSld>
     <p:spTree>
       <p:nvGrpSpPr>
-        <p:cNvPr id="1" name="Shape 169"/>
+        <p:cNvPr id="1" name="Shape 160"/>
         <p:cNvGrpSpPr/>
         <p:nvPr/>
       </p:nvGrpSpPr>
@@ -1023,7 +1024,7 @@
       </p:grpSpPr>
       <p:sp>
         <p:nvSpPr>
-          <p:cNvPr id="170" name="Google Shape;170;g33d320e3551_0_398:notes"/>
+          <p:cNvPr id="161" name="Google Shape;161;g33d320e3551_0_369:notes"/>
           <p:cNvSpPr>
             <a:spLocks noGrp="1" noRot="1" noChangeAspect="1"/>
           </p:cNvSpPr>
@@ -1064,7 +1065,7 @@
       </p:sp>
       <p:sp>
         <p:nvSpPr>
-          <p:cNvPr id="171" name="Google Shape;171;g33d320e3551_0_398:notes"/>
+          <p:cNvPr id="162" name="Google Shape;162;g33d320e3551_0_369:notes"/>
           <p:cNvSpPr txBox="1">
             <a:spLocks noGrp="1"/>
           </p:cNvSpPr>
@@ -1113,7 +1114,7 @@
   <p:cSld>
     <p:spTree>
       <p:nvGrpSpPr>
-        <p:cNvPr id="1" name="Shape 178"/>
+        <p:cNvPr id="1" name="Shape 169"/>
         <p:cNvGrpSpPr/>
         <p:nvPr/>
       </p:nvGrpSpPr>
@@ -1127,7 +1128,7 @@
       </p:grpSpPr>
       <p:sp>
         <p:nvSpPr>
-          <p:cNvPr id="179" name="Google Shape;179;g33d320e3551_0_377:notes"/>
+          <p:cNvPr id="170" name="Google Shape;170;g33d320e3551_0_398:notes"/>
           <p:cNvSpPr>
             <a:spLocks noGrp="1" noRot="1" noChangeAspect="1"/>
           </p:cNvSpPr>
@@ -1168,7 +1169,7 @@
       </p:sp>
       <p:sp>
         <p:nvSpPr>
-          <p:cNvPr id="180" name="Google Shape;180;g33d320e3551_0_377:notes"/>
+          <p:cNvPr id="171" name="Google Shape;171;g33d320e3551_0_398:notes"/>
           <p:cNvSpPr txBox="1">
             <a:spLocks noGrp="1"/>
           </p:cNvSpPr>
@@ -1217,7 +1218,7 @@
   <p:cSld>
     <p:spTree>
       <p:nvGrpSpPr>
-        <p:cNvPr id="1" name="Shape 187"/>
+        <p:cNvPr id="1" name="Shape 178"/>
         <p:cNvGrpSpPr/>
         <p:nvPr/>
       </p:nvGrpSpPr>
@@ -1231,7 +1232,7 @@
       </p:grpSpPr>
       <p:sp>
         <p:nvSpPr>
-          <p:cNvPr id="188" name="Google Shape;188;g33d320e3551_0_406:notes"/>
+          <p:cNvPr id="179" name="Google Shape;179;g33d320e3551_0_377:notes"/>
           <p:cNvSpPr>
             <a:spLocks noGrp="1" noRot="1" noChangeAspect="1"/>
           </p:cNvSpPr>
@@ -1272,7 +1273,7 @@
       </p:sp>
       <p:sp>
         <p:nvSpPr>
-          <p:cNvPr id="189" name="Google Shape;189;g33d320e3551_0_406:notes"/>
+          <p:cNvPr id="180" name="Google Shape;180;g33d320e3551_0_377:notes"/>
           <p:cNvSpPr txBox="1">
             <a:spLocks noGrp="1"/>
           </p:cNvSpPr>
@@ -1321,7 +1322,7 @@
   <p:cSld>
     <p:spTree>
       <p:nvGrpSpPr>
-        <p:cNvPr id="1" name="Shape 197"/>
+        <p:cNvPr id="1" name="Shape 187"/>
         <p:cNvGrpSpPr/>
         <p:nvPr/>
       </p:nvGrpSpPr>
@@ -1335,7 +1336,7 @@
       </p:grpSpPr>
       <p:sp>
         <p:nvSpPr>
-          <p:cNvPr id="198" name="Google Shape;198;g33d320e3551_0_16:notes"/>
+          <p:cNvPr id="188" name="Google Shape;188;g33d320e3551_0_406:notes"/>
           <p:cNvSpPr>
             <a:spLocks noGrp="1" noRot="1" noChangeAspect="1"/>
           </p:cNvSpPr>
@@ -1376,7 +1377,7 @@
       </p:sp>
       <p:sp>
         <p:nvSpPr>
-          <p:cNvPr id="199" name="Google Shape;199;g33d320e3551_0_16:notes"/>
+          <p:cNvPr id="189" name="Google Shape;189;g33d320e3551_0_406:notes"/>
           <p:cNvSpPr txBox="1">
             <a:spLocks noGrp="1"/>
           </p:cNvSpPr>
@@ -1425,7 +1426,7 @@
   <p:cSld>
     <p:spTree>
       <p:nvGrpSpPr>
-        <p:cNvPr id="1" name="Shape 207"/>
+        <p:cNvPr id="1" name="Shape 197"/>
         <p:cNvGrpSpPr/>
         <p:nvPr/>
       </p:nvGrpSpPr>
@@ -1439,7 +1440,7 @@
       </p:grpSpPr>
       <p:sp>
         <p:nvSpPr>
-          <p:cNvPr id="208" name="Google Shape;208;g33d320e3551_0_75:notes"/>
+          <p:cNvPr id="198" name="Google Shape;198;g33d320e3551_0_16:notes"/>
           <p:cNvSpPr>
             <a:spLocks noGrp="1" noRot="1" noChangeAspect="1"/>
           </p:cNvSpPr>
@@ -1480,7 +1481,7 @@
       </p:sp>
       <p:sp>
         <p:nvSpPr>
-          <p:cNvPr id="209" name="Google Shape;209;g33d320e3551_0_75:notes"/>
+          <p:cNvPr id="199" name="Google Shape;199;g33d320e3551_0_16:notes"/>
           <p:cNvSpPr txBox="1">
             <a:spLocks noGrp="1"/>
           </p:cNvSpPr>
@@ -1529,7 +1530,7 @@
   <p:cSld>
     <p:spTree>
       <p:nvGrpSpPr>
-        <p:cNvPr id="1" name="Shape 218"/>
+        <p:cNvPr id="1" name="Shape 207"/>
         <p:cNvGrpSpPr/>
         <p:nvPr/>
       </p:nvGrpSpPr>
@@ -1543,7 +1544,7 @@
       </p:grpSpPr>
       <p:sp>
         <p:nvSpPr>
-          <p:cNvPr id="219" name="Google Shape;219;g33d320e3551_0_21:notes"/>
+          <p:cNvPr id="208" name="Google Shape;208;g33d320e3551_0_75:notes"/>
           <p:cNvSpPr>
             <a:spLocks noGrp="1" noRot="1" noChangeAspect="1"/>
           </p:cNvSpPr>
@@ -1584,7 +1585,7 @@
       </p:sp>
       <p:sp>
         <p:nvSpPr>
-          <p:cNvPr id="220" name="Google Shape;220;g33d320e3551_0_21:notes"/>
+          <p:cNvPr id="209" name="Google Shape;209;g33d320e3551_0_75:notes"/>
           <p:cNvSpPr txBox="1">
             <a:spLocks noGrp="1"/>
           </p:cNvSpPr>
@@ -1633,7 +1634,7 @@
   <p:cSld>
     <p:spTree>
       <p:nvGrpSpPr>
-        <p:cNvPr id="1" name="Shape 228"/>
+        <p:cNvPr id="1" name="Shape 218"/>
         <p:cNvGrpSpPr/>
         <p:nvPr/>
       </p:nvGrpSpPr>
@@ -1647,7 +1648,7 @@
       </p:grpSpPr>
       <p:sp>
         <p:nvSpPr>
-          <p:cNvPr id="229" name="Google Shape;229;g36a627ac3a3_0_2:notes"/>
+          <p:cNvPr id="219" name="Google Shape;219;g33d320e3551_0_21:notes"/>
           <p:cNvSpPr>
             <a:spLocks noGrp="1" noRot="1" noChangeAspect="1"/>
           </p:cNvSpPr>
@@ -1688,7 +1689,7 @@
       </p:sp>
       <p:sp>
         <p:nvSpPr>
-          <p:cNvPr id="230" name="Google Shape;230;g36a627ac3a3_0_2:notes"/>
+          <p:cNvPr id="220" name="Google Shape;220;g33d320e3551_0_21:notes"/>
           <p:cNvSpPr txBox="1">
             <a:spLocks noGrp="1"/>
           </p:cNvSpPr>
@@ -1841,7 +1842,7 @@
   <p:cSld>
     <p:spTree>
       <p:nvGrpSpPr>
-        <p:cNvPr id="1" name="Shape 238"/>
+        <p:cNvPr id="1" name="Shape 228"/>
         <p:cNvGrpSpPr/>
         <p:nvPr/>
       </p:nvGrpSpPr>
@@ -1855,7 +1856,7 @@
       </p:grpSpPr>
       <p:sp>
         <p:nvSpPr>
-          <p:cNvPr id="239" name="Google Shape;239;g36a627ac3a3_0_15:notes"/>
+          <p:cNvPr id="229" name="Google Shape;229;g36a627ac3a3_0_2:notes"/>
           <p:cNvSpPr>
             <a:spLocks noGrp="1" noRot="1" noChangeAspect="1"/>
           </p:cNvSpPr>
@@ -1896,7 +1897,7 @@
       </p:sp>
       <p:sp>
         <p:nvSpPr>
-          <p:cNvPr id="240" name="Google Shape;240;g36a627ac3a3_0_15:notes"/>
+          <p:cNvPr id="230" name="Google Shape;230;g36a627ac3a3_0_2:notes"/>
           <p:cNvSpPr txBox="1">
             <a:spLocks noGrp="1"/>
           </p:cNvSpPr>
@@ -1945,7 +1946,7 @@
   <p:cSld>
     <p:spTree>
       <p:nvGrpSpPr>
-        <p:cNvPr id="1" name="Shape 244"/>
+        <p:cNvPr id="1" name="Shape 238"/>
         <p:cNvGrpSpPr/>
         <p:nvPr/>
       </p:nvGrpSpPr>
@@ -1959,7 +1960,7 @@
       </p:grpSpPr>
       <p:sp>
         <p:nvSpPr>
-          <p:cNvPr id="245" name="Google Shape;245;g36a627ac3a3_0_26:notes"/>
+          <p:cNvPr id="239" name="Google Shape;239;g36a627ac3a3_0_15:notes"/>
           <p:cNvSpPr>
             <a:spLocks noGrp="1" noRot="1" noChangeAspect="1"/>
           </p:cNvSpPr>
@@ -2000,7 +2001,7 @@
       </p:sp>
       <p:sp>
         <p:nvSpPr>
-          <p:cNvPr id="246" name="Google Shape;246;g36a627ac3a3_0_26:notes"/>
+          <p:cNvPr id="240" name="Google Shape;240;g36a627ac3a3_0_15:notes"/>
           <p:cNvSpPr txBox="1">
             <a:spLocks noGrp="1"/>
           </p:cNvSpPr>
@@ -2049,7 +2050,7 @@
   <p:cSld>
     <p:spTree>
       <p:nvGrpSpPr>
-        <p:cNvPr id="1" name="Shape 254"/>
+        <p:cNvPr id="1" name="Shape 244"/>
         <p:cNvGrpSpPr/>
         <p:nvPr/>
       </p:nvGrpSpPr>
@@ -2063,7 +2064,7 @@
       </p:grpSpPr>
       <p:sp>
         <p:nvSpPr>
-          <p:cNvPr id="255" name="Google Shape;255;g33d320e3551_0_26:notes"/>
+          <p:cNvPr id="245" name="Google Shape;245;g36a627ac3a3_0_26:notes"/>
           <p:cNvSpPr>
             <a:spLocks noGrp="1" noRot="1" noChangeAspect="1"/>
           </p:cNvSpPr>
@@ -2104,7 +2105,7 @@
       </p:sp>
       <p:sp>
         <p:nvSpPr>
-          <p:cNvPr id="256" name="Google Shape;256;g33d320e3551_0_26:notes"/>
+          <p:cNvPr id="246" name="Google Shape;246;g36a627ac3a3_0_26:notes"/>
           <p:cNvSpPr txBox="1">
             <a:spLocks noGrp="1"/>
           </p:cNvSpPr>
@@ -2148,12 +2149,12 @@
 </p:notes>
 </file>
 
-<file path=ppt/notesSlides/notesSlide3.xml><?xml version="1.0" encoding="utf-8"?>
+<file path=ppt/notesSlides/notesSlide23.xml><?xml version="1.0" encoding="utf-8"?>
 <p:notes xmlns:a="http://schemas.openxmlformats.org/drawingml/2006/main" xmlns:r="http://schemas.openxmlformats.org/officeDocument/2006/relationships" xmlns:p="http://schemas.openxmlformats.org/presentationml/2006/main" showMasterSp="0" showMasterPhAnim="0">
   <p:cSld>
     <p:spTree>
       <p:nvGrpSpPr>
-        <p:cNvPr id="1" name="Shape 70"/>
+        <p:cNvPr id="1" name="Shape 254"/>
         <p:cNvGrpSpPr/>
         <p:nvPr/>
       </p:nvGrpSpPr>
@@ -2167,7 +2168,7 @@
       </p:grpSpPr>
       <p:sp>
         <p:nvSpPr>
-          <p:cNvPr id="71" name="Google Shape;71;g33d320e3551_0_32:notes"/>
+          <p:cNvPr id="255" name="Google Shape;255;g33d320e3551_0_26:notes"/>
           <p:cNvSpPr>
             <a:spLocks noGrp="1" noRot="1" noChangeAspect="1"/>
           </p:cNvSpPr>
@@ -2208,7 +2209,7 @@
       </p:sp>
       <p:sp>
         <p:nvSpPr>
-          <p:cNvPr id="72" name="Google Shape;72;g33d320e3551_0_32:notes"/>
+          <p:cNvPr id="256" name="Google Shape;256;g33d320e3551_0_26:notes"/>
           <p:cNvSpPr txBox="1">
             <a:spLocks noGrp="1"/>
           </p:cNvSpPr>
@@ -2252,12 +2253,12 @@
 </p:notes>
 </file>
 
-<file path=ppt/notesSlides/notesSlide4.xml><?xml version="1.0" encoding="utf-8"?>
+<file path=ppt/notesSlides/notesSlide3.xml><?xml version="1.0" encoding="utf-8"?>
 <p:notes xmlns:a="http://schemas.openxmlformats.org/drawingml/2006/main" xmlns:r="http://schemas.openxmlformats.org/officeDocument/2006/relationships" xmlns:p="http://schemas.openxmlformats.org/presentationml/2006/main" showMasterSp="0" showMasterPhAnim="0">
   <p:cSld>
     <p:spTree>
       <p:nvGrpSpPr>
-        <p:cNvPr id="1" name="Shape 79"/>
+        <p:cNvPr id="1" name="Shape 60"/>
         <p:cNvGrpSpPr/>
         <p:nvPr/>
       </p:nvGrpSpPr>
@@ -2271,7 +2272,7 @@
       </p:grpSpPr>
       <p:sp>
         <p:nvSpPr>
-          <p:cNvPr id="80" name="Google Shape;80;g33d320e3551_0_313:notes"/>
+          <p:cNvPr id="61" name="Google Shape;61;g33d320e3551_0_6:notes"/>
           <p:cNvSpPr>
             <a:spLocks noGrp="1" noRot="1" noChangeAspect="1"/>
           </p:cNvSpPr>
@@ -2312,7 +2313,7 @@
       </p:sp>
       <p:sp>
         <p:nvSpPr>
-          <p:cNvPr id="81" name="Google Shape;81;g33d320e3551_0_313:notes"/>
+          <p:cNvPr id="62" name="Google Shape;62;g33d320e3551_0_6:notes"/>
           <p:cNvSpPr txBox="1">
             <a:spLocks noGrp="1"/>
           </p:cNvSpPr>
@@ -2349,6 +2350,11 @@
         </p:txBody>
       </p:sp>
     </p:spTree>
+    <p:extLst>
+      <p:ext uri="{BB962C8B-B14F-4D97-AF65-F5344CB8AC3E}">
+        <p14:creationId xmlns:p14="http://schemas.microsoft.com/office/powerpoint/2010/main" val="1705493497"/>
+      </p:ext>
+    </p:extLst>
   </p:cSld>
   <p:clrMapOvr>
     <a:masterClrMapping/>
@@ -2356,12 +2362,12 @@
 </p:notes>
 </file>
 
-<file path=ppt/notesSlides/notesSlide5.xml><?xml version="1.0" encoding="utf-8"?>
+<file path=ppt/notesSlides/notesSlide4.xml><?xml version="1.0" encoding="utf-8"?>
 <p:notes xmlns:a="http://schemas.openxmlformats.org/drawingml/2006/main" xmlns:r="http://schemas.openxmlformats.org/officeDocument/2006/relationships" xmlns:p="http://schemas.openxmlformats.org/presentationml/2006/main" showMasterSp="0" showMasterPhAnim="0">
   <p:cSld>
     <p:spTree>
       <p:nvGrpSpPr>
-        <p:cNvPr id="1" name="Shape 89"/>
+        <p:cNvPr id="1" name="Shape 70"/>
         <p:cNvGrpSpPr/>
         <p:nvPr/>
       </p:nvGrpSpPr>
@@ -2375,7 +2381,7 @@
       </p:grpSpPr>
       <p:sp>
         <p:nvSpPr>
-          <p:cNvPr id="90" name="Google Shape;90;g33d320e3551_0_322:notes"/>
+          <p:cNvPr id="71" name="Google Shape;71;g33d320e3551_0_32:notes"/>
           <p:cNvSpPr>
             <a:spLocks noGrp="1" noRot="1" noChangeAspect="1"/>
           </p:cNvSpPr>
@@ -2416,7 +2422,7 @@
       </p:sp>
       <p:sp>
         <p:nvSpPr>
-          <p:cNvPr id="91" name="Google Shape;91;g33d320e3551_0_322:notes"/>
+          <p:cNvPr id="72" name="Google Shape;72;g33d320e3551_0_32:notes"/>
           <p:cNvSpPr txBox="1">
             <a:spLocks noGrp="1"/>
           </p:cNvSpPr>
@@ -2460,12 +2466,12 @@
 </p:notes>
 </file>
 
-<file path=ppt/notesSlides/notesSlide6.xml><?xml version="1.0" encoding="utf-8"?>
+<file path=ppt/notesSlides/notesSlide5.xml><?xml version="1.0" encoding="utf-8"?>
 <p:notes xmlns:a="http://schemas.openxmlformats.org/drawingml/2006/main" xmlns:r="http://schemas.openxmlformats.org/officeDocument/2006/relationships" xmlns:p="http://schemas.openxmlformats.org/presentationml/2006/main" showMasterSp="0" showMasterPhAnim="0">
   <p:cSld>
     <p:spTree>
       <p:nvGrpSpPr>
-        <p:cNvPr id="1" name="Shape 98"/>
+        <p:cNvPr id="1" name="Shape 79"/>
         <p:cNvGrpSpPr/>
         <p:nvPr/>
       </p:nvGrpSpPr>
@@ -2479,7 +2485,7 @@
       </p:grpSpPr>
       <p:sp>
         <p:nvSpPr>
-          <p:cNvPr id="99" name="Google Shape;99;g33d320e3551_0_330:notes"/>
+          <p:cNvPr id="80" name="Google Shape;80;g33d320e3551_0_313:notes"/>
           <p:cNvSpPr>
             <a:spLocks noGrp="1" noRot="1" noChangeAspect="1"/>
           </p:cNvSpPr>
@@ -2520,7 +2526,7 @@
       </p:sp>
       <p:sp>
         <p:nvSpPr>
-          <p:cNvPr id="100" name="Google Shape;100;g33d320e3551_0_330:notes"/>
+          <p:cNvPr id="81" name="Google Shape;81;g33d320e3551_0_313:notes"/>
           <p:cNvSpPr txBox="1">
             <a:spLocks noGrp="1"/>
           </p:cNvSpPr>
@@ -2564,12 +2570,12 @@
 </p:notes>
 </file>
 
-<file path=ppt/notesSlides/notesSlide7.xml><?xml version="1.0" encoding="utf-8"?>
+<file path=ppt/notesSlides/notesSlide6.xml><?xml version="1.0" encoding="utf-8"?>
 <p:notes xmlns:a="http://schemas.openxmlformats.org/drawingml/2006/main" xmlns:r="http://schemas.openxmlformats.org/officeDocument/2006/relationships" xmlns:p="http://schemas.openxmlformats.org/presentationml/2006/main" showMasterSp="0" showMasterPhAnim="0">
   <p:cSld>
     <p:spTree>
       <p:nvGrpSpPr>
-        <p:cNvPr id="1" name="Shape 110"/>
+        <p:cNvPr id="1" name="Shape 89"/>
         <p:cNvGrpSpPr/>
         <p:nvPr/>
       </p:nvGrpSpPr>
@@ -2583,7 +2589,7 @@
       </p:grpSpPr>
       <p:sp>
         <p:nvSpPr>
-          <p:cNvPr id="111" name="Google Shape;111;g33d320e3551_0_341:notes"/>
+          <p:cNvPr id="90" name="Google Shape;90;g33d320e3551_0_322:notes"/>
           <p:cNvSpPr>
             <a:spLocks noGrp="1" noRot="1" noChangeAspect="1"/>
           </p:cNvSpPr>
@@ -2624,7 +2630,7 @@
       </p:sp>
       <p:sp>
         <p:nvSpPr>
-          <p:cNvPr id="112" name="Google Shape;112;g33d320e3551_0_341:notes"/>
+          <p:cNvPr id="91" name="Google Shape;91;g33d320e3551_0_322:notes"/>
           <p:cNvSpPr txBox="1">
             <a:spLocks noGrp="1"/>
           </p:cNvSpPr>
@@ -2668,12 +2674,12 @@
 </p:notes>
 </file>
 
-<file path=ppt/notesSlides/notesSlide8.xml><?xml version="1.0" encoding="utf-8"?>
+<file path=ppt/notesSlides/notesSlide7.xml><?xml version="1.0" encoding="utf-8"?>
 <p:notes xmlns:a="http://schemas.openxmlformats.org/drawingml/2006/main" xmlns:r="http://schemas.openxmlformats.org/officeDocument/2006/relationships" xmlns:p="http://schemas.openxmlformats.org/presentationml/2006/main" showMasterSp="0" showMasterPhAnim="0">
   <p:cSld>
     <p:spTree>
       <p:nvGrpSpPr>
-        <p:cNvPr id="1" name="Shape 122"/>
+        <p:cNvPr id="1" name="Shape 98"/>
         <p:cNvGrpSpPr/>
         <p:nvPr/>
       </p:nvGrpSpPr>
@@ -2687,7 +2693,7 @@
       </p:grpSpPr>
       <p:sp>
         <p:nvSpPr>
-          <p:cNvPr id="123" name="Google Shape;123;g33d320e3551_0_352:notes"/>
+          <p:cNvPr id="99" name="Google Shape;99;g33d320e3551_0_330:notes"/>
           <p:cNvSpPr>
             <a:spLocks noGrp="1" noRot="1" noChangeAspect="1"/>
           </p:cNvSpPr>
@@ -2728,7 +2734,7 @@
       </p:sp>
       <p:sp>
         <p:nvSpPr>
-          <p:cNvPr id="124" name="Google Shape;124;g33d320e3551_0_352:notes"/>
+          <p:cNvPr id="100" name="Google Shape;100;g33d320e3551_0_330:notes"/>
           <p:cNvSpPr txBox="1">
             <a:spLocks noGrp="1"/>
           </p:cNvSpPr>
@@ -2772,12 +2778,12 @@
 </p:notes>
 </file>
 
-<file path=ppt/notesSlides/notesSlide9.xml><?xml version="1.0" encoding="utf-8"?>
+<file path=ppt/notesSlides/notesSlide8.xml><?xml version="1.0" encoding="utf-8"?>
 <p:notes xmlns:a="http://schemas.openxmlformats.org/drawingml/2006/main" xmlns:r="http://schemas.openxmlformats.org/officeDocument/2006/relationships" xmlns:p="http://schemas.openxmlformats.org/presentationml/2006/main" showMasterSp="0" showMasterPhAnim="0">
   <p:cSld>
     <p:spTree>
       <p:nvGrpSpPr>
-        <p:cNvPr id="1" name="Shape 131"/>
+        <p:cNvPr id="1" name="Shape 110"/>
         <p:cNvGrpSpPr/>
         <p:nvPr/>
       </p:nvGrpSpPr>
@@ -2791,7 +2797,7 @@
       </p:grpSpPr>
       <p:sp>
         <p:nvSpPr>
-          <p:cNvPr id="132" name="Google Shape;132;g33d320e3551_0_360:notes"/>
+          <p:cNvPr id="111" name="Google Shape;111;g33d320e3551_0_341:notes"/>
           <p:cNvSpPr>
             <a:spLocks noGrp="1" noRot="1" noChangeAspect="1"/>
           </p:cNvSpPr>
@@ -2832,7 +2838,111 @@
       </p:sp>
       <p:sp>
         <p:nvSpPr>
-          <p:cNvPr id="133" name="Google Shape;133;g33d320e3551_0_360:notes"/>
+          <p:cNvPr id="112" name="Google Shape;112;g33d320e3551_0_341:notes"/>
+          <p:cNvSpPr txBox="1">
+            <a:spLocks noGrp="1"/>
+          </p:cNvSpPr>
+          <p:nvPr>
+            <p:ph type="body" idx="1"/>
+          </p:nvPr>
+        </p:nvSpPr>
+        <p:spPr>
+          <a:xfrm>
+            <a:off x="685800" y="4343400"/>
+            <a:ext cx="5486400" cy="4114800"/>
+          </a:xfrm>
+          <a:prstGeom prst="rect">
+            <a:avLst/>
+          </a:prstGeom>
+        </p:spPr>
+        <p:txBody>
+          <a:bodyPr spcFirstLastPara="1" wrap="square" lIns="91425" tIns="91425" rIns="91425" bIns="91425" anchor="t" anchorCtr="0">
+            <a:noAutofit/>
+          </a:bodyPr>
+          <a:lstStyle/>
+          <a:p>
+            <a:pPr marL="0" lvl="0" indent="0" algn="l" rtl="0">
+              <a:spcBef>
+                <a:spcPts val="0"/>
+              </a:spcBef>
+              <a:spcAft>
+                <a:spcPts val="0"/>
+              </a:spcAft>
+              <a:buNone/>
+            </a:pPr>
+            <a:endParaRPr/>
+          </a:p>
+        </p:txBody>
+      </p:sp>
+    </p:spTree>
+  </p:cSld>
+  <p:clrMapOvr>
+    <a:masterClrMapping/>
+  </p:clrMapOvr>
+</p:notes>
+</file>
+
+<file path=ppt/notesSlides/notesSlide9.xml><?xml version="1.0" encoding="utf-8"?>
+<p:notes xmlns:a="http://schemas.openxmlformats.org/drawingml/2006/main" xmlns:r="http://schemas.openxmlformats.org/officeDocument/2006/relationships" xmlns:p="http://schemas.openxmlformats.org/presentationml/2006/main" showMasterSp="0" showMasterPhAnim="0">
+  <p:cSld>
+    <p:spTree>
+      <p:nvGrpSpPr>
+        <p:cNvPr id="1" name="Shape 122"/>
+        <p:cNvGrpSpPr/>
+        <p:nvPr/>
+      </p:nvGrpSpPr>
+      <p:grpSpPr>
+        <a:xfrm>
+          <a:off x="0" y="0"/>
+          <a:ext cx="0" cy="0"/>
+          <a:chOff x="0" y="0"/>
+          <a:chExt cx="0" cy="0"/>
+        </a:xfrm>
+      </p:grpSpPr>
+      <p:sp>
+        <p:nvSpPr>
+          <p:cNvPr id="123" name="Google Shape;123;g33d320e3551_0_352:notes"/>
+          <p:cNvSpPr>
+            <a:spLocks noGrp="1" noRot="1" noChangeAspect="1"/>
+          </p:cNvSpPr>
+          <p:nvPr>
+            <p:ph type="sldImg" idx="2"/>
+          </p:nvPr>
+        </p:nvSpPr>
+        <p:spPr>
+          <a:xfrm>
+            <a:off x="381000" y="685800"/>
+            <a:ext cx="6096000" cy="3429000"/>
+          </a:xfrm>
+          <a:custGeom>
+            <a:avLst/>
+            <a:gdLst/>
+            <a:ahLst/>
+            <a:cxnLst/>
+            <a:rect l="l" t="t" r="r" b="b"/>
+            <a:pathLst>
+              <a:path w="120000" h="120000" extrusionOk="0">
+                <a:moveTo>
+                  <a:pt x="0" y="0"/>
+                </a:moveTo>
+                <a:lnTo>
+                  <a:pt x="120000" y="0"/>
+                </a:lnTo>
+                <a:lnTo>
+                  <a:pt x="120000" y="120000"/>
+                </a:lnTo>
+                <a:lnTo>
+                  <a:pt x="0" y="120000"/>
+                </a:lnTo>
+                <a:close/>
+              </a:path>
+            </a:pathLst>
+          </a:custGeom>
+        </p:spPr>
+      </p:sp>
+      <p:sp>
+        <p:nvSpPr>
+          <p:cNvPr id="124" name="Google Shape;124;g33d320e3551_0_352:notes"/>
           <p:cNvSpPr txBox="1">
             <a:spLocks noGrp="1"/>
           </p:cNvSpPr>
@@ -3279,7 +3389,7 @@
           <a:p>
             <a:fld id="{96DFF08F-DC6B-4601-B491-B0F83F6DD2DA}" type="datetimeFigureOut">
               <a:rPr lang="en-US" smtClean="0"/>
-              <a:t>6/23/2025</a:t>
+              <a:t>6/24/2025</a:t>
             </a:fld>
             <a:endParaRPr lang="en-US" dirty="0"/>
           </a:p>
@@ -3468,7 +3578,7 @@
           <a:p>
             <a:fld id="{96DFF08F-DC6B-4601-B491-B0F83F6DD2DA}" type="datetimeFigureOut">
               <a:rPr lang="en-US" smtClean="0"/>
-              <a:t>6/23/2025</a:t>
+              <a:t>6/24/2025</a:t>
             </a:fld>
             <a:endParaRPr lang="en-US" dirty="0"/>
           </a:p>
@@ -3658,7 +3768,7 @@
           <a:p>
             <a:fld id="{96DFF08F-DC6B-4601-B491-B0F83F6DD2DA}" type="datetimeFigureOut">
               <a:rPr lang="en-US" smtClean="0"/>
-              <a:t>6/23/2025</a:t>
+              <a:t>6/24/2025</a:t>
             </a:fld>
             <a:endParaRPr lang="en-US" dirty="0"/>
           </a:p>
@@ -4205,7 +4315,7 @@
           <a:p>
             <a:fld id="{96DFF08F-DC6B-4601-B491-B0F83F6DD2DA}" type="datetimeFigureOut">
               <a:rPr lang="en-US" smtClean="0"/>
-              <a:t>6/23/2025</a:t>
+              <a:t>6/24/2025</a:t>
             </a:fld>
             <a:endParaRPr lang="en-US" dirty="0"/>
           </a:p>
@@ -4528,7 +4638,7 @@
           <a:p>
             <a:fld id="{96DFF08F-DC6B-4601-B491-B0F83F6DD2DA}" type="datetimeFigureOut">
               <a:rPr lang="en-US" smtClean="0"/>
-              <a:t>6/23/2025</a:t>
+              <a:t>6/24/2025</a:t>
             </a:fld>
             <a:endParaRPr lang="en-US" dirty="0"/>
           </a:p>
@@ -4924,7 +5034,7 @@
           <a:p>
             <a:fld id="{96DFF08F-DC6B-4601-B491-B0F83F6DD2DA}" type="datetimeFigureOut">
               <a:rPr lang="en-US" smtClean="0"/>
-              <a:t>6/23/2025</a:t>
+              <a:t>6/24/2025</a:t>
             </a:fld>
             <a:endParaRPr lang="en-US" dirty="0"/>
           </a:p>
@@ -5368,7 +5478,7 @@
           <a:p>
             <a:fld id="{96DFF08F-DC6B-4601-B491-B0F83F6DD2DA}" type="datetimeFigureOut">
               <a:rPr lang="en-US" smtClean="0"/>
-              <a:t>6/23/2025</a:t>
+              <a:t>6/24/2025</a:t>
             </a:fld>
             <a:endParaRPr lang="en-US" dirty="0"/>
           </a:p>
@@ -5496,7 +5606,7 @@
           <a:p>
             <a:fld id="{96DFF08F-DC6B-4601-B491-B0F83F6DD2DA}" type="datetimeFigureOut">
               <a:rPr lang="en-US" smtClean="0"/>
-              <a:t>6/23/2025</a:t>
+              <a:t>6/24/2025</a:t>
             </a:fld>
             <a:endParaRPr lang="en-US" dirty="0"/>
           </a:p>
@@ -5601,7 +5711,7 @@
           <a:p>
             <a:fld id="{96DFF08F-DC6B-4601-B491-B0F83F6DD2DA}" type="datetimeFigureOut">
               <a:rPr lang="en-US" smtClean="0"/>
-              <a:t>6/23/2025</a:t>
+              <a:t>6/24/2025</a:t>
             </a:fld>
             <a:endParaRPr lang="en-US" dirty="0"/>
           </a:p>
@@ -5960,7 +6070,7 @@
           <a:p>
             <a:fld id="{96DFF08F-DC6B-4601-B491-B0F83F6DD2DA}" type="datetimeFigureOut">
               <a:rPr lang="en-US" smtClean="0"/>
-              <a:t>6/23/2025</a:t>
+              <a:t>6/24/2025</a:t>
             </a:fld>
             <a:endParaRPr lang="en-US" dirty="0"/>
           </a:p>
@@ -6395,7 +6505,7 @@
           <a:p>
             <a:fld id="{96DFF08F-DC6B-4601-B491-B0F83F6DD2DA}" type="datetimeFigureOut">
               <a:rPr lang="en-US" smtClean="0"/>
-              <a:t>6/23/2025</a:t>
+              <a:t>6/24/2025</a:t>
             </a:fld>
             <a:endParaRPr lang="en-US" dirty="0"/>
           </a:p>
@@ -6687,7 +6797,7 @@
             <a:fld id="{96DFF08F-DC6B-4601-B491-B0F83F6DD2DA}" type="datetimeFigureOut">
               <a:rPr lang="en-US" smtClean="0"/>
               <a:pPr/>
-              <a:t>6/23/2025</a:t>
+              <a:t>6/24/2025</a:t>
             </a:fld>
             <a:endParaRPr lang="en-US" dirty="0"/>
           </a:p>
@@ -7578,14 +7688,14 @@
               <a:buNone/>
             </a:pPr>
             <a:r>
-              <a:rPr lang="en-GB" sz="800">
+              <a:rPr lang="en-GB" sz="800" dirty="0">
                 <a:solidFill>
                   <a:schemeClr val="dk2"/>
                 </a:solidFill>
               </a:rPr>
-              <a:t>Page 1</a:t>
-            </a:r>
-            <a:endParaRPr sz="800">
+              <a:t>Page 1: presenter Emaan</a:t>
+            </a:r>
+            <a:endParaRPr sz="800" dirty="0">
               <a:solidFill>
                 <a:schemeClr val="dk2"/>
               </a:solidFill>
@@ -7602,6 +7712,307 @@
 </file>
 
 <file path=ppt/slides/slide10.xml><?xml version="1.0" encoding="utf-8"?>
+<p:sld xmlns:a="http://schemas.openxmlformats.org/drawingml/2006/main" xmlns:r="http://schemas.openxmlformats.org/officeDocument/2006/relationships" xmlns:p="http://schemas.openxmlformats.org/presentationml/2006/main">
+  <p:cSld>
+    <p:spTree>
+      <p:nvGrpSpPr>
+        <p:cNvPr id="1" name="Shape 134"/>
+        <p:cNvGrpSpPr/>
+        <p:nvPr/>
+      </p:nvGrpSpPr>
+      <p:grpSpPr>
+        <a:xfrm>
+          <a:off x="0" y="0"/>
+          <a:ext cx="0" cy="0"/>
+          <a:chOff x="0" y="0"/>
+          <a:chExt cx="0" cy="0"/>
+        </a:xfrm>
+      </p:grpSpPr>
+      <p:sp>
+        <p:nvSpPr>
+          <p:cNvPr id="135" name="Google Shape;135;p21"/>
+          <p:cNvSpPr txBox="1"/>
+          <p:nvPr/>
+        </p:nvSpPr>
+        <p:spPr>
+          <a:xfrm>
+            <a:off x="0" y="0"/>
+            <a:ext cx="1662900" cy="266100"/>
+          </a:xfrm>
+          <a:prstGeom prst="rect">
+            <a:avLst/>
+          </a:prstGeom>
+          <a:noFill/>
+          <a:ln>
+            <a:noFill/>
+          </a:ln>
+        </p:spPr>
+        <p:txBody>
+          <a:bodyPr spcFirstLastPara="1" wrap="square" lIns="91425" tIns="91425" rIns="91425" bIns="91425" anchor="t" anchorCtr="0">
+            <a:noAutofit/>
+          </a:bodyPr>
+          <a:lstStyle/>
+          <a:p>
+            <a:pPr marL="0" lvl="0" indent="0" algn="l" rtl="0">
+              <a:spcBef>
+                <a:spcPts val="0"/>
+              </a:spcBef>
+              <a:spcAft>
+                <a:spcPts val="0"/>
+              </a:spcAft>
+              <a:buNone/>
+            </a:pPr>
+            <a:r>
+              <a:rPr lang="en-GB" sz="800">
+                <a:solidFill>
+                  <a:schemeClr val="dk2"/>
+                </a:solidFill>
+              </a:rPr>
+              <a:t>Hardware Engineering Lab</a:t>
+            </a:r>
+            <a:endParaRPr sz="800">
+              <a:solidFill>
+                <a:schemeClr val="dk2"/>
+              </a:solidFill>
+            </a:endParaRPr>
+          </a:p>
+        </p:txBody>
+      </p:sp>
+      <p:sp>
+        <p:nvSpPr>
+          <p:cNvPr id="136" name="Google Shape;136;p21"/>
+          <p:cNvSpPr txBox="1"/>
+          <p:nvPr/>
+        </p:nvSpPr>
+        <p:spPr>
+          <a:xfrm>
+            <a:off x="7481100" y="0"/>
+            <a:ext cx="1662900" cy="266100"/>
+          </a:xfrm>
+          <a:prstGeom prst="rect">
+            <a:avLst/>
+          </a:prstGeom>
+          <a:noFill/>
+          <a:ln>
+            <a:noFill/>
+          </a:ln>
+        </p:spPr>
+        <p:txBody>
+          <a:bodyPr spcFirstLastPara="1" wrap="square" lIns="91425" tIns="91425" rIns="91425" bIns="91425" anchor="t" anchorCtr="0">
+            <a:noAutofit/>
+          </a:bodyPr>
+          <a:lstStyle/>
+          <a:p>
+            <a:pPr marL="0" lvl="0" indent="0" algn="r" rtl="0">
+              <a:spcBef>
+                <a:spcPts val="0"/>
+              </a:spcBef>
+              <a:spcAft>
+                <a:spcPts val="0"/>
+              </a:spcAft>
+              <a:buNone/>
+            </a:pPr>
+            <a:r>
+              <a:rPr lang="en-GB" sz="800">
+                <a:solidFill>
+                  <a:schemeClr val="dk2"/>
+                </a:solidFill>
+              </a:rPr>
+              <a:t>Summer Term 2025</a:t>
+            </a:r>
+            <a:endParaRPr sz="800">
+              <a:solidFill>
+                <a:schemeClr val="dk2"/>
+              </a:solidFill>
+            </a:endParaRPr>
+          </a:p>
+        </p:txBody>
+      </p:sp>
+      <p:sp>
+        <p:nvSpPr>
+          <p:cNvPr id="137" name="Google Shape;137;p21"/>
+          <p:cNvSpPr txBox="1"/>
+          <p:nvPr/>
+        </p:nvSpPr>
+        <p:spPr>
+          <a:xfrm>
+            <a:off x="3783275" y="4877400"/>
+            <a:ext cx="1662900" cy="266100"/>
+          </a:xfrm>
+          <a:prstGeom prst="rect">
+            <a:avLst/>
+          </a:prstGeom>
+          <a:noFill/>
+          <a:ln>
+            <a:noFill/>
+          </a:ln>
+        </p:spPr>
+        <p:txBody>
+          <a:bodyPr spcFirstLastPara="1" wrap="square" lIns="91425" tIns="91425" rIns="91425" bIns="91425" anchor="t" anchorCtr="0">
+            <a:noAutofit/>
+          </a:bodyPr>
+          <a:lstStyle/>
+          <a:p>
+            <a:pPr lvl="0" algn="ctr"/>
+            <a:r>
+              <a:rPr lang="en-GB" sz="800" dirty="0">
+                <a:solidFill>
+                  <a:schemeClr val="dk2"/>
+                </a:solidFill>
+              </a:rPr>
+              <a:t>Page 9 : presenter Leano</a:t>
+            </a:r>
+            <a:endParaRPr sz="800" dirty="0">
+              <a:solidFill>
+                <a:schemeClr val="dk2"/>
+              </a:solidFill>
+            </a:endParaRPr>
+          </a:p>
+        </p:txBody>
+      </p:sp>
+      <p:sp>
+        <p:nvSpPr>
+          <p:cNvPr id="138" name="Google Shape;138;p21"/>
+          <p:cNvSpPr txBox="1">
+            <a:spLocks noGrp="1"/>
+          </p:cNvSpPr>
+          <p:nvPr>
+            <p:ph type="title"/>
+          </p:nvPr>
+        </p:nvSpPr>
+        <p:spPr>
+          <a:xfrm>
+            <a:off x="46725" y="266100"/>
+            <a:ext cx="8520600" cy="572700"/>
+          </a:xfrm>
+          <a:prstGeom prst="rect">
+            <a:avLst/>
+          </a:prstGeom>
+        </p:spPr>
+        <p:txBody>
+          <a:bodyPr spcFirstLastPara="1" wrap="square" lIns="91425" tIns="91425" rIns="91425" bIns="91425" anchor="t" anchorCtr="0">
+            <a:normAutofit fontScale="90000"/>
+          </a:bodyPr>
+          <a:lstStyle/>
+          <a:p>
+            <a:pPr marL="0" lvl="0" indent="0" algn="l" rtl="0">
+              <a:spcBef>
+                <a:spcPts val="0"/>
+              </a:spcBef>
+              <a:spcAft>
+                <a:spcPts val="0"/>
+              </a:spcAft>
+              <a:buClr>
+                <a:schemeClr val="dk1"/>
+              </a:buClr>
+              <a:buSzPct val="39285"/>
+              <a:buFont typeface="Arial"/>
+              <a:buNone/>
+            </a:pPr>
+            <a:r>
+              <a:rPr lang="en-GB"/>
+              <a:t>VHDL Code Implementations</a:t>
+            </a:r>
+            <a:endParaRPr/>
+          </a:p>
+          <a:p>
+            <a:pPr marL="3657600" lvl="0" indent="457200" algn="l" rtl="0">
+              <a:lnSpc>
+                <a:spcPct val="115000"/>
+              </a:lnSpc>
+              <a:spcBef>
+                <a:spcPts val="0"/>
+              </a:spcBef>
+              <a:spcAft>
+                <a:spcPts val="0"/>
+              </a:spcAft>
+              <a:buNone/>
+            </a:pPr>
+            <a:r>
+              <a:rPr lang="en-GB"/>
+              <a:t>Display_Manager.vhd</a:t>
+            </a:r>
+            <a:endParaRPr/>
+          </a:p>
+          <a:p>
+            <a:pPr marL="0" lvl="0" indent="0" algn="l" rtl="0">
+              <a:spcBef>
+                <a:spcPts val="1200"/>
+              </a:spcBef>
+              <a:spcAft>
+                <a:spcPts val="0"/>
+              </a:spcAft>
+              <a:buNone/>
+            </a:pPr>
+            <a:endParaRPr/>
+          </a:p>
+        </p:txBody>
+      </p:sp>
+      <p:pic>
+        <p:nvPicPr>
+          <p:cNvPr id="139" name="Google Shape;139;p21" title="Display_Manager_1.PNG"/>
+          <p:cNvPicPr preferRelativeResize="0"/>
+          <p:nvPr/>
+        </p:nvPicPr>
+        <p:blipFill>
+          <a:blip r:embed="rId3">
+            <a:alphaModFix/>
+          </a:blip>
+          <a:stretch>
+            <a:fillRect/>
+          </a:stretch>
+        </p:blipFill>
+        <p:spPr>
+          <a:xfrm>
+            <a:off x="325225" y="898550"/>
+            <a:ext cx="3670950" cy="4120074"/>
+          </a:xfrm>
+          <a:prstGeom prst="rect">
+            <a:avLst/>
+          </a:prstGeom>
+          <a:noFill/>
+          <a:ln>
+            <a:noFill/>
+          </a:ln>
+        </p:spPr>
+      </p:pic>
+      <p:pic>
+        <p:nvPicPr>
+          <p:cNvPr id="140" name="Google Shape;140;p21"/>
+          <p:cNvPicPr preferRelativeResize="0"/>
+          <p:nvPr/>
+        </p:nvPicPr>
+        <p:blipFill>
+          <a:blip r:embed="rId4">
+            <a:alphaModFix/>
+          </a:blip>
+          <a:stretch>
+            <a:fillRect/>
+          </a:stretch>
+        </p:blipFill>
+        <p:spPr>
+          <a:xfrm>
+            <a:off x="4284575" y="1794700"/>
+            <a:ext cx="3641450" cy="3147175"/>
+          </a:xfrm>
+          <a:prstGeom prst="rect">
+            <a:avLst/>
+          </a:prstGeom>
+          <a:noFill/>
+          <a:ln>
+            <a:noFill/>
+          </a:ln>
+        </p:spPr>
+      </p:pic>
+    </p:spTree>
+  </p:cSld>
+  <p:clrMapOvr>
+    <a:masterClrMapping/>
+  </p:clrMapOvr>
+</p:sld>
+</file>
+
+<file path=ppt/slides/slide11.xml><?xml version="1.0" encoding="utf-8"?>
 <p:sld xmlns:a="http://schemas.openxmlformats.org/drawingml/2006/main" xmlns:r="http://schemas.openxmlformats.org/officeDocument/2006/relationships" xmlns:p="http://schemas.openxmlformats.org/presentationml/2006/main">
   <p:cSld>
     <p:spTree>
@@ -8323,24 +8734,16 @@
           </a:bodyPr>
           <a:lstStyle/>
           <a:p>
-            <a:pPr marL="0" lvl="0" indent="0" algn="ctr" rtl="0">
-              <a:spcBef>
-                <a:spcPts val="0"/>
-              </a:spcBef>
-              <a:spcAft>
-                <a:spcPts val="0"/>
-              </a:spcAft>
-              <a:buNone/>
-            </a:pPr>
-            <a:r>
-              <a:rPr lang="en-GB" sz="800">
+            <a:pPr lvl="0" algn="ctr"/>
+            <a:r>
+              <a:rPr lang="en-GB" sz="800" dirty="0">
                 <a:solidFill>
                   <a:schemeClr val="dk2"/>
                 </a:solidFill>
               </a:rPr>
-              <a:t>Page 10</a:t>
-            </a:r>
-            <a:endParaRPr sz="800">
+              <a:t>Page 10 : presenter Choi</a:t>
+            </a:r>
+            <a:endParaRPr sz="800" dirty="0">
               <a:solidFill>
                 <a:schemeClr val="dk2"/>
               </a:solidFill>
@@ -8432,7 +8835,7 @@
 </p:sld>
 </file>
 
-<file path=ppt/slides/slide11.xml><?xml version="1.0" encoding="utf-8"?>
+<file path=ppt/slides/slide12.xml><?xml version="1.0" encoding="utf-8"?>
 <p:sld xmlns:a="http://schemas.openxmlformats.org/drawingml/2006/main" xmlns:r="http://schemas.openxmlformats.org/officeDocument/2006/relationships" xmlns:p="http://schemas.openxmlformats.org/presentationml/2006/main">
   <p:cSld>
     <p:spTree>
@@ -8715,7 +9118,7 @@
 </p:sld>
 </file>
 
-<file path=ppt/slides/slide12.xml><?xml version="1.0" encoding="utf-8"?>
+<file path=ppt/slides/slide13.xml><?xml version="1.0" encoding="utf-8"?>
 <p:sld xmlns:a="http://schemas.openxmlformats.org/drawingml/2006/main" xmlns:r="http://schemas.openxmlformats.org/officeDocument/2006/relationships" xmlns:p="http://schemas.openxmlformats.org/presentationml/2006/main">
   <p:cSld>
     <p:spTree>
@@ -9177,22 +9580,14 @@
           </a:bodyPr>
           <a:lstStyle/>
           <a:p>
-            <a:pPr marL="0" lvl="0" indent="0" algn="ctr" rtl="0">
-              <a:spcBef>
-                <a:spcPts val="0"/>
-              </a:spcBef>
-              <a:spcAft>
-                <a:spcPts val="0"/>
-              </a:spcAft>
-              <a:buNone/>
-            </a:pPr>
+            <a:pPr lvl="0" algn="ctr"/>
             <a:r>
               <a:rPr lang="en-GB" sz="800" dirty="0">
                 <a:solidFill>
                   <a:schemeClr val="dk2"/>
                 </a:solidFill>
               </a:rPr>
-              <a:t>Page 12</a:t>
+              <a:t>Page 12 : presenter Choi</a:t>
             </a:r>
             <a:endParaRPr sz="800" dirty="0">
               <a:solidFill>
@@ -9210,7 +9605,7 @@
 </p:sld>
 </file>
 
-<file path=ppt/slides/slide13.xml><?xml version="1.0" encoding="utf-8"?>
+<file path=ppt/slides/slide14.xml><?xml version="1.0" encoding="utf-8"?>
 <p:sld xmlns:a="http://schemas.openxmlformats.org/drawingml/2006/main" xmlns:r="http://schemas.openxmlformats.org/officeDocument/2006/relationships" xmlns:p="http://schemas.openxmlformats.org/presentationml/2006/main">
   <p:cSld>
     <p:spTree>
@@ -9459,7 +9854,7 @@
 </p:sld>
 </file>
 
-<file path=ppt/slides/slide14.xml><?xml version="1.0" encoding="utf-8"?>
+<file path=ppt/slides/slide15.xml><?xml version="1.0" encoding="utf-8"?>
 <p:sld xmlns:a="http://schemas.openxmlformats.org/drawingml/2006/main" xmlns:r="http://schemas.openxmlformats.org/officeDocument/2006/relationships" xmlns:p="http://schemas.openxmlformats.org/presentationml/2006/main">
   <p:cSld>
     <p:spTree>
@@ -9876,22 +10271,14 @@
           </a:bodyPr>
           <a:lstStyle/>
           <a:p>
-            <a:pPr marL="0" lvl="0" indent="0" algn="ctr" rtl="0">
-              <a:spcBef>
-                <a:spcPts val="0"/>
-              </a:spcBef>
-              <a:spcAft>
-                <a:spcPts val="0"/>
-              </a:spcAft>
-              <a:buNone/>
-            </a:pPr>
+            <a:pPr lvl="0" algn="ctr"/>
             <a:r>
               <a:rPr lang="en-GB" sz="800" dirty="0">
                 <a:solidFill>
                   <a:schemeClr val="dk2"/>
                 </a:solidFill>
               </a:rPr>
-              <a:t>Page 14</a:t>
+              <a:t>Page 14 : presenter Choi</a:t>
             </a:r>
             <a:endParaRPr sz="800" dirty="0">
               <a:solidFill>
@@ -9909,7 +10296,7 @@
 </p:sld>
 </file>
 
-<file path=ppt/slides/slide15.xml><?xml version="1.0" encoding="utf-8"?>
+<file path=ppt/slides/slide16.xml><?xml version="1.0" encoding="utf-8"?>
 <p:sld xmlns:a="http://schemas.openxmlformats.org/drawingml/2006/main" xmlns:r="http://schemas.openxmlformats.org/officeDocument/2006/relationships" xmlns:p="http://schemas.openxmlformats.org/presentationml/2006/main">
   <p:cSld>
     <p:spTree>
@@ -10192,7 +10579,7 @@
 </p:sld>
 </file>
 
-<file path=ppt/slides/slide16.xml><?xml version="1.0" encoding="utf-8"?>
+<file path=ppt/slides/slide17.xml><?xml version="1.0" encoding="utf-8"?>
 <p:sld xmlns:a="http://schemas.openxmlformats.org/drawingml/2006/main" xmlns:r="http://schemas.openxmlformats.org/officeDocument/2006/relationships" xmlns:p="http://schemas.openxmlformats.org/presentationml/2006/main">
   <p:cSld>
     <p:spTree>
@@ -10372,22 +10759,14 @@
           </a:bodyPr>
           <a:lstStyle/>
           <a:p>
-            <a:pPr marL="0" lvl="0" indent="0" algn="ctr" rtl="0">
-              <a:spcBef>
-                <a:spcPts val="0"/>
-              </a:spcBef>
-              <a:spcAft>
-                <a:spcPts val="0"/>
-              </a:spcAft>
-              <a:buNone/>
-            </a:pPr>
+            <a:pPr lvl="0" algn="ctr"/>
             <a:r>
               <a:rPr lang="en-GB" sz="800" dirty="0">
                 <a:solidFill>
                   <a:schemeClr val="dk2"/>
                 </a:solidFill>
               </a:rPr>
-              <a:t>Page 16</a:t>
+              <a:t>Page 16 : presenter Leano</a:t>
             </a:r>
             <a:endParaRPr sz="800" dirty="0">
               <a:solidFill>
@@ -10459,7 +10838,7 @@
 </p:sld>
 </file>
 
-<file path=ppt/slides/slide17.xml><?xml version="1.0" encoding="utf-8"?>
+<file path=ppt/slides/slide18.xml><?xml version="1.0" encoding="utf-8"?>
 <p:sld xmlns:a="http://schemas.openxmlformats.org/drawingml/2006/main" xmlns:r="http://schemas.openxmlformats.org/officeDocument/2006/relationships" xmlns:p="http://schemas.openxmlformats.org/presentationml/2006/main">
   <p:cSld>
     <p:spTree>
@@ -10723,22 +11102,14 @@
           </a:bodyPr>
           <a:lstStyle/>
           <a:p>
-            <a:pPr marL="0" lvl="0" indent="0" algn="ctr" rtl="0">
-              <a:spcBef>
-                <a:spcPts val="0"/>
-              </a:spcBef>
-              <a:spcAft>
-                <a:spcPts val="0"/>
-              </a:spcAft>
-              <a:buNone/>
-            </a:pPr>
+            <a:pPr lvl="0" algn="ctr"/>
             <a:r>
               <a:rPr lang="en-GB" sz="800" dirty="0">
                 <a:solidFill>
                   <a:schemeClr val="dk2"/>
                 </a:solidFill>
               </a:rPr>
-              <a:t>Page 17</a:t>
+              <a:t>Page 17 : presenter Leano</a:t>
             </a:r>
             <a:endParaRPr sz="800" dirty="0">
               <a:solidFill>
@@ -10859,7 +11230,7 @@
 </p:sld>
 </file>
 
-<file path=ppt/slides/slide18.xml><?xml version="1.0" encoding="utf-8"?>
+<file path=ppt/slides/slide19.xml><?xml version="1.0" encoding="utf-8"?>
 <p:sld xmlns:a="http://schemas.openxmlformats.org/drawingml/2006/main" xmlns:r="http://schemas.openxmlformats.org/officeDocument/2006/relationships" xmlns:p="http://schemas.openxmlformats.org/presentationml/2006/main">
   <p:cSld>
     <p:spTree>
@@ -10925,6 +11296,10 @@
           </p:nvPr>
         </p:nvSpPr>
         <p:spPr>
+          <a:xfrm>
+            <a:off x="311700" y="1152475"/>
+            <a:ext cx="8520600" cy="2846501"/>
+          </a:xfrm>
           <a:prstGeom prst="rect">
             <a:avLst/>
           </a:prstGeom>
@@ -10935,18 +11310,16 @@
           </a:bodyPr>
           <a:lstStyle/>
           <a:p>
-            <a:pPr marL="0" lvl="0" indent="0" algn="l" rtl="0">
-              <a:spcBef>
-                <a:spcPts val="0"/>
-              </a:spcBef>
-              <a:spcAft>
-                <a:spcPts val="0"/>
-              </a:spcAft>
-              <a:buNone/>
-            </a:pPr>
+            <a:pPr marL="0" lvl="0" indent="0">
+              <a:buNone/>
+            </a:pPr>
+            <a:r>
+              <a:rPr lang="en-US" dirty="0"/>
+              <a:t>PCB Prototyping is a process of designing printed circuit boards in which we electrically connect electronic components. Some known process of PCB Prototype</a:t>
+            </a:r>
             <a:r>
               <a:rPr lang="en-GB" dirty="0"/>
-              <a:t>PCB design is a process of designing printed circuit boards in which we electrically connect electronic components. Some known process of PCB Design </a:t>
+              <a:t> </a:t>
             </a:r>
             <a:endParaRPr dirty="0"/>
           </a:p>
@@ -11118,23 +11491,6 @@
               <a:rPr lang="en-GB" dirty="0"/>
               <a:t>Final production </a:t>
             </a:r>
-            <a:endParaRPr dirty="0"/>
-          </a:p>
-          <a:p>
-            <a:pPr marL="0" lvl="0" indent="0" algn="l" rtl="0">
-              <a:spcBef>
-                <a:spcPts val="1200"/>
-              </a:spcBef>
-              <a:spcAft>
-                <a:spcPts val="1200"/>
-              </a:spcAft>
-              <a:buNone/>
-            </a:pPr>
-            <a:r>
-              <a:rPr lang="en-GB" dirty="0"/>
-              <a:t> </a:t>
-            </a:r>
-            <a:endParaRPr dirty="0"/>
           </a:p>
         </p:txBody>
       </p:sp>
@@ -11263,22 +11619,14 @@
           </a:bodyPr>
           <a:lstStyle/>
           <a:p>
-            <a:pPr marL="0" lvl="0" indent="0" algn="ctr" rtl="0">
-              <a:spcBef>
-                <a:spcPts val="0"/>
-              </a:spcBef>
-              <a:spcAft>
-                <a:spcPts val="0"/>
-              </a:spcAft>
-              <a:buNone/>
-            </a:pPr>
+            <a:pPr lvl="0" algn="ctr"/>
             <a:r>
               <a:rPr lang="en-GB" sz="800" dirty="0">
                 <a:solidFill>
                   <a:schemeClr val="dk2"/>
                 </a:solidFill>
               </a:rPr>
-              <a:t>Page 18</a:t>
+              <a:t>Page 18 : presenter Emaan</a:t>
             </a:r>
             <a:endParaRPr sz="800" dirty="0">
               <a:solidFill>
@@ -11316,686 +11664,6 @@
           </a:ln>
         </p:spPr>
       </p:pic>
-    </p:spTree>
-  </p:cSld>
-  <p:clrMapOvr>
-    <a:masterClrMapping/>
-  </p:clrMapOvr>
-</p:sld>
-</file>
-
-<file path=ppt/slides/slide19.xml><?xml version="1.0" encoding="utf-8"?>
-<p:sld xmlns:a="http://schemas.openxmlformats.org/drawingml/2006/main" xmlns:r="http://schemas.openxmlformats.org/officeDocument/2006/relationships" xmlns:p="http://schemas.openxmlformats.org/presentationml/2006/main">
-  <p:cSld>
-    <p:spTree>
-      <p:nvGrpSpPr>
-        <p:cNvPr id="1" name="Shape 231"/>
-        <p:cNvGrpSpPr/>
-        <p:nvPr/>
-      </p:nvGrpSpPr>
-      <p:grpSpPr>
-        <a:xfrm>
-          <a:off x="0" y="0"/>
-          <a:ext cx="0" cy="0"/>
-          <a:chOff x="0" y="0"/>
-          <a:chExt cx="0" cy="0"/>
-        </a:xfrm>
-      </p:grpSpPr>
-      <p:sp>
-        <p:nvSpPr>
-          <p:cNvPr id="232" name="Google Shape;232;p31"/>
-          <p:cNvSpPr txBox="1">
-            <a:spLocks noGrp="1"/>
-          </p:cNvSpPr>
-          <p:nvPr>
-            <p:ph type="title"/>
-          </p:nvPr>
-        </p:nvSpPr>
-        <p:spPr>
-          <a:prstGeom prst="rect">
-            <a:avLst/>
-          </a:prstGeom>
-        </p:spPr>
-        <p:txBody>
-          <a:bodyPr spcFirstLastPara="1" wrap="square" lIns="91425" tIns="91425" rIns="91425" bIns="91425" anchor="t" anchorCtr="0">
-            <a:normAutofit fontScale="90000"/>
-          </a:bodyPr>
-          <a:lstStyle/>
-          <a:p>
-            <a:pPr marL="0" lvl="0" indent="0" algn="l" rtl="0">
-              <a:spcBef>
-                <a:spcPts val="0"/>
-              </a:spcBef>
-              <a:spcAft>
-                <a:spcPts val="0"/>
-              </a:spcAft>
-              <a:buNone/>
-            </a:pPr>
-            <a:r>
-              <a:rPr lang="en-GB"/>
-              <a:t>PCB Prototyping</a:t>
-            </a:r>
-            <a:endParaRPr/>
-          </a:p>
-        </p:txBody>
-      </p:sp>
-      <p:sp>
-        <p:nvSpPr>
-          <p:cNvPr id="233" name="Google Shape;233;p31"/>
-          <p:cNvSpPr txBox="1">
-            <a:spLocks noGrp="1"/>
-          </p:cNvSpPr>
-          <p:nvPr>
-            <p:ph type="body" idx="1"/>
-          </p:nvPr>
-        </p:nvSpPr>
-        <p:spPr>
-          <a:xfrm>
-            <a:off x="311699" y="1152475"/>
-            <a:ext cx="3600061" cy="3459600"/>
-          </a:xfrm>
-          <a:prstGeom prst="rect">
-            <a:avLst/>
-          </a:prstGeom>
-        </p:spPr>
-        <p:txBody>
-          <a:bodyPr spcFirstLastPara="1" wrap="square" lIns="91425" tIns="91425" rIns="91425" bIns="91425" anchor="t" anchorCtr="0">
-            <a:normAutofit/>
-          </a:bodyPr>
-          <a:lstStyle/>
-          <a:p>
-            <a:pPr marL="0" lvl="0" indent="0" algn="l" rtl="0">
-              <a:spcBef>
-                <a:spcPts val="0"/>
-              </a:spcBef>
-              <a:spcAft>
-                <a:spcPts val="0"/>
-              </a:spcAft>
-              <a:buNone/>
-            </a:pPr>
-            <a:r>
-              <a:rPr lang="en-GB" sz="1100" dirty="0">
-                <a:solidFill>
-                  <a:schemeClr val="dk1"/>
-                </a:solidFill>
-              </a:rPr>
-              <a:t>After discussion and deep analysis we select these elements for our PCB </a:t>
-            </a:r>
-            <a:endParaRPr sz="1100" dirty="0">
-              <a:solidFill>
-                <a:schemeClr val="dk1"/>
-              </a:solidFill>
-            </a:endParaRPr>
-          </a:p>
-          <a:p>
-            <a:pPr marL="457200" lvl="0" indent="-298450" algn="l" rtl="0">
-              <a:lnSpc>
-                <a:spcPct val="100000"/>
-              </a:lnSpc>
-              <a:spcBef>
-                <a:spcPts val="1200"/>
-              </a:spcBef>
-              <a:spcAft>
-                <a:spcPts val="0"/>
-              </a:spcAft>
-              <a:buClr>
-                <a:schemeClr val="dk1"/>
-              </a:buClr>
-              <a:buSzPts val="1100"/>
-              <a:buChar char="●"/>
-            </a:pPr>
-            <a:r>
-              <a:rPr lang="en-GB" sz="1100" dirty="0">
-                <a:solidFill>
-                  <a:schemeClr val="dk1"/>
-                </a:solidFill>
-              </a:rPr>
-              <a:t>Two 7 segment display</a:t>
-            </a:r>
-            <a:endParaRPr sz="1100" dirty="0">
-              <a:solidFill>
-                <a:schemeClr val="dk1"/>
-              </a:solidFill>
-            </a:endParaRPr>
-          </a:p>
-          <a:p>
-            <a:pPr marL="457200" lvl="0" indent="-298450" algn="l" rtl="0">
-              <a:spcBef>
-                <a:spcPts val="0"/>
-              </a:spcBef>
-              <a:spcAft>
-                <a:spcPts val="0"/>
-              </a:spcAft>
-              <a:buClr>
-                <a:schemeClr val="dk1"/>
-              </a:buClr>
-              <a:buSzPts val="1100"/>
-              <a:buChar char="●"/>
-            </a:pPr>
-            <a:r>
-              <a:rPr lang="en-GB" sz="1100" dirty="0">
-                <a:solidFill>
-                  <a:schemeClr val="dk1"/>
-                </a:solidFill>
-              </a:rPr>
-              <a:t>power supply</a:t>
-            </a:r>
-            <a:endParaRPr sz="1100" dirty="0">
-              <a:solidFill>
-                <a:schemeClr val="dk1"/>
-              </a:solidFill>
-            </a:endParaRPr>
-          </a:p>
-          <a:p>
-            <a:pPr marL="457200" lvl="0" indent="-298450" algn="l" rtl="0">
-              <a:spcBef>
-                <a:spcPts val="0"/>
-              </a:spcBef>
-              <a:spcAft>
-                <a:spcPts val="0"/>
-              </a:spcAft>
-              <a:buClr>
-                <a:schemeClr val="dk1"/>
-              </a:buClr>
-              <a:buSzPts val="1100"/>
-              <a:buChar char="●"/>
-            </a:pPr>
-            <a:r>
-              <a:rPr lang="en-GB" sz="1100" dirty="0">
-                <a:solidFill>
-                  <a:schemeClr val="dk1"/>
-                </a:solidFill>
-              </a:rPr>
-              <a:t>Resistors and Capacitors</a:t>
-            </a:r>
-            <a:endParaRPr sz="1100" dirty="0">
-              <a:solidFill>
-                <a:schemeClr val="dk1"/>
-              </a:solidFill>
-            </a:endParaRPr>
-          </a:p>
-          <a:p>
-            <a:pPr marL="457200" lvl="0" indent="-298450" algn="l" rtl="0">
-              <a:spcBef>
-                <a:spcPts val="0"/>
-              </a:spcBef>
-              <a:spcAft>
-                <a:spcPts val="0"/>
-              </a:spcAft>
-              <a:buClr>
-                <a:schemeClr val="dk1"/>
-              </a:buClr>
-              <a:buSzPts val="1100"/>
-              <a:buChar char="●"/>
-            </a:pPr>
-            <a:r>
-              <a:rPr lang="en-GB" sz="1100" dirty="0">
-                <a:solidFill>
-                  <a:schemeClr val="dk1"/>
-                </a:solidFill>
-              </a:rPr>
-              <a:t>Central component is the Nexus A7 </a:t>
-            </a:r>
-            <a:r>
-              <a:rPr lang="en-GB" sz="1100" i="1" dirty="0">
-                <a:solidFill>
-                  <a:schemeClr val="dk1"/>
-                </a:solidFill>
-              </a:rPr>
-              <a:t>XC7A100T </a:t>
-            </a:r>
-            <a:r>
-              <a:rPr lang="en-GB" sz="1100" dirty="0">
-                <a:solidFill>
-                  <a:schemeClr val="dk1"/>
-                </a:solidFill>
-              </a:rPr>
-              <a:t>FPGA, handling all control logic and I/O</a:t>
-            </a:r>
-            <a:endParaRPr sz="1100" dirty="0">
-              <a:solidFill>
-                <a:schemeClr val="dk1"/>
-              </a:solidFill>
-            </a:endParaRPr>
-          </a:p>
-          <a:p>
-            <a:pPr marL="457200" lvl="0" indent="-298450" algn="l" rtl="0">
-              <a:spcBef>
-                <a:spcPts val="0"/>
-              </a:spcBef>
-              <a:spcAft>
-                <a:spcPts val="0"/>
-              </a:spcAft>
-              <a:buClr>
-                <a:schemeClr val="dk1"/>
-              </a:buClr>
-              <a:buSzPts val="1100"/>
-              <a:buChar char="●"/>
-            </a:pPr>
-            <a:r>
-              <a:rPr lang="en-GB" sz="1100" dirty="0">
-                <a:solidFill>
-                  <a:schemeClr val="dk1"/>
-                </a:solidFill>
-              </a:rPr>
-              <a:t>Connected to multiple push buttons for item selection and user interaction.</a:t>
-            </a:r>
-            <a:endParaRPr sz="1100" dirty="0">
-              <a:solidFill>
-                <a:schemeClr val="dk1"/>
-              </a:solidFill>
-            </a:endParaRPr>
-          </a:p>
-          <a:p>
-            <a:pPr marL="457200" lvl="0" indent="-298450" algn="l" rtl="0">
-              <a:spcBef>
-                <a:spcPts val="0"/>
-              </a:spcBef>
-              <a:spcAft>
-                <a:spcPts val="0"/>
-              </a:spcAft>
-              <a:buClr>
-                <a:schemeClr val="dk1"/>
-              </a:buClr>
-              <a:buSzPts val="1100"/>
-              <a:buChar char="●"/>
-            </a:pPr>
-            <a:r>
-              <a:rPr lang="en-GB" sz="1100" b="1" dirty="0">
-                <a:solidFill>
-                  <a:schemeClr val="dk1"/>
-                </a:solidFill>
-              </a:rPr>
-              <a:t>PNP and NPN transistors control outputs like relays or motors, acting as switches via FPGA signals.</a:t>
-            </a:r>
-            <a:endParaRPr sz="1100" b="1" dirty="0">
-              <a:solidFill>
-                <a:schemeClr val="dk1"/>
-              </a:solidFill>
-            </a:endParaRPr>
-          </a:p>
-        </p:txBody>
-      </p:sp>
-      <p:pic>
-        <p:nvPicPr>
-          <p:cNvPr id="234" name="Google Shape;234;p31"/>
-          <p:cNvPicPr preferRelativeResize="0"/>
-          <p:nvPr/>
-        </p:nvPicPr>
-        <p:blipFill>
-          <a:blip r:embed="rId3">
-            <a:alphaModFix/>
-          </a:blip>
-          <a:stretch>
-            <a:fillRect/>
-          </a:stretch>
-        </p:blipFill>
-        <p:spPr>
-          <a:xfrm>
-            <a:off x="3978662" y="244902"/>
-            <a:ext cx="4724824" cy="3003451"/>
-          </a:xfrm>
-          <a:prstGeom prst="rect">
-            <a:avLst/>
-          </a:prstGeom>
-          <a:noFill/>
-          <a:ln>
-            <a:noFill/>
-          </a:ln>
-        </p:spPr>
-      </p:pic>
-      <p:pic>
-        <p:nvPicPr>
-          <p:cNvPr id="235" name="Google Shape;235;p31"/>
-          <p:cNvPicPr preferRelativeResize="0"/>
-          <p:nvPr/>
-        </p:nvPicPr>
-        <p:blipFill>
-          <a:blip r:embed="rId4">
-            <a:alphaModFix/>
-          </a:blip>
-          <a:stretch>
-            <a:fillRect/>
-          </a:stretch>
-        </p:blipFill>
-        <p:spPr>
-          <a:xfrm rot="16200000">
-            <a:off x="5458361" y="3337500"/>
-            <a:ext cx="1604026" cy="1741874"/>
-          </a:xfrm>
-          <a:prstGeom prst="rect">
-            <a:avLst/>
-          </a:prstGeom>
-          <a:noFill/>
-          <a:ln>
-            <a:noFill/>
-          </a:ln>
-        </p:spPr>
-      </p:pic>
-      <p:sp>
-        <p:nvSpPr>
-          <p:cNvPr id="236" name="Google Shape;236;p31"/>
-          <p:cNvSpPr txBox="1"/>
-          <p:nvPr/>
-        </p:nvSpPr>
-        <p:spPr>
-          <a:xfrm>
-            <a:off x="2375023" y="5568913"/>
-            <a:ext cx="1121700" cy="323100"/>
-          </a:xfrm>
-          <a:prstGeom prst="rect">
-            <a:avLst/>
-          </a:prstGeom>
-          <a:noFill/>
-          <a:ln>
-            <a:noFill/>
-          </a:ln>
-        </p:spPr>
-        <p:txBody>
-          <a:bodyPr spcFirstLastPara="1" wrap="square" lIns="91425" tIns="91425" rIns="91425" bIns="91425" anchor="t" anchorCtr="0">
-            <a:spAutoFit/>
-          </a:bodyPr>
-          <a:lstStyle/>
-          <a:p>
-            <a:pPr marL="0" lvl="0" indent="0" algn="l" rtl="0">
-              <a:spcBef>
-                <a:spcPts val="0"/>
-              </a:spcBef>
-              <a:spcAft>
-                <a:spcPts val="0"/>
-              </a:spcAft>
-              <a:buNone/>
-            </a:pPr>
-            <a:r>
-              <a:rPr lang="en-GB" sz="900" dirty="0">
-                <a:solidFill>
-                  <a:schemeClr val="dk2"/>
-                </a:solidFill>
-              </a:rPr>
-              <a:t>Schematics</a:t>
-            </a:r>
-            <a:endParaRPr sz="900" dirty="0">
-              <a:solidFill>
-                <a:schemeClr val="dk2"/>
-              </a:solidFill>
-            </a:endParaRPr>
-          </a:p>
-        </p:txBody>
-      </p:sp>
-      <p:sp>
-        <p:nvSpPr>
-          <p:cNvPr id="237" name="Google Shape;237;p31"/>
-          <p:cNvSpPr txBox="1"/>
-          <p:nvPr/>
-        </p:nvSpPr>
-        <p:spPr>
-          <a:xfrm>
-            <a:off x="7198213" y="4663801"/>
-            <a:ext cx="1121700" cy="323100"/>
-          </a:xfrm>
-          <a:prstGeom prst="rect">
-            <a:avLst/>
-          </a:prstGeom>
-          <a:noFill/>
-          <a:ln>
-            <a:noFill/>
-          </a:ln>
-        </p:spPr>
-        <p:txBody>
-          <a:bodyPr spcFirstLastPara="1" wrap="square" lIns="91425" tIns="91425" rIns="91425" bIns="91425" anchor="t" anchorCtr="0">
-            <a:spAutoFit/>
-          </a:bodyPr>
-          <a:lstStyle/>
-          <a:p>
-            <a:pPr marL="0" lvl="0" indent="0" algn="l" rtl="0">
-              <a:spcBef>
-                <a:spcPts val="0"/>
-              </a:spcBef>
-              <a:spcAft>
-                <a:spcPts val="0"/>
-              </a:spcAft>
-              <a:buNone/>
-            </a:pPr>
-            <a:r>
-              <a:rPr lang="en-GB" sz="900" dirty="0">
-                <a:solidFill>
-                  <a:schemeClr val="dk2"/>
-                </a:solidFill>
-              </a:rPr>
-              <a:t>3D View</a:t>
-            </a:r>
-            <a:endParaRPr sz="900" dirty="0">
-              <a:solidFill>
-                <a:schemeClr val="dk2"/>
-              </a:solidFill>
-            </a:endParaRPr>
-          </a:p>
-        </p:txBody>
-      </p:sp>
-      <p:sp>
-        <p:nvSpPr>
-          <p:cNvPr id="8" name="Google Shape;226;p30">
-            <a:extLst>
-              <a:ext uri="{FF2B5EF4-FFF2-40B4-BE49-F238E27FC236}">
-                <a16:creationId xmlns:a16="http://schemas.microsoft.com/office/drawing/2014/main" id="{D519478A-A558-4C1D-B352-7EBEE7A18BD9}"/>
-              </a:ext>
-            </a:extLst>
-          </p:cNvPr>
-          <p:cNvSpPr txBox="1"/>
-          <p:nvPr/>
-        </p:nvSpPr>
-        <p:spPr>
-          <a:xfrm>
-            <a:off x="3783275" y="4877400"/>
-            <a:ext cx="1662900" cy="266100"/>
-          </a:xfrm>
-          <a:prstGeom prst="rect">
-            <a:avLst/>
-          </a:prstGeom>
-          <a:noFill/>
-          <a:ln>
-            <a:noFill/>
-          </a:ln>
-        </p:spPr>
-        <p:txBody>
-          <a:bodyPr spcFirstLastPara="1" wrap="square" lIns="91425" tIns="91425" rIns="91425" bIns="91425" anchor="t" anchorCtr="0">
-            <a:noAutofit/>
-          </a:bodyPr>
-          <a:lstStyle/>
-          <a:p>
-            <a:pPr marL="0" lvl="0" indent="0" algn="ctr" rtl="0">
-              <a:spcBef>
-                <a:spcPts val="0"/>
-              </a:spcBef>
-              <a:spcAft>
-                <a:spcPts val="0"/>
-              </a:spcAft>
-              <a:buNone/>
-            </a:pPr>
-            <a:r>
-              <a:rPr lang="en-GB" sz="800" dirty="0">
-                <a:solidFill>
-                  <a:schemeClr val="dk2"/>
-                </a:solidFill>
-              </a:rPr>
-              <a:t>Page 19</a:t>
-            </a:r>
-            <a:endParaRPr sz="800" dirty="0">
-              <a:solidFill>
-                <a:schemeClr val="dk2"/>
-              </a:solidFill>
-            </a:endParaRPr>
-          </a:p>
-        </p:txBody>
-      </p:sp>
-      <p:sp>
-        <p:nvSpPr>
-          <p:cNvPr id="9" name="Google Shape;237;p31">
-            <a:extLst>
-              <a:ext uri="{FF2B5EF4-FFF2-40B4-BE49-F238E27FC236}">
-                <a16:creationId xmlns:a16="http://schemas.microsoft.com/office/drawing/2014/main" id="{A1BA26F8-BAC7-4F8C-9055-DA03B8999E59}"/>
-              </a:ext>
-            </a:extLst>
-          </p:cNvPr>
-          <p:cNvSpPr txBox="1"/>
-          <p:nvPr/>
-        </p:nvSpPr>
-        <p:spPr>
-          <a:xfrm>
-            <a:off x="7710600" y="3286926"/>
-            <a:ext cx="1121700" cy="323100"/>
-          </a:xfrm>
-          <a:prstGeom prst="rect">
-            <a:avLst/>
-          </a:prstGeom>
-          <a:noFill/>
-          <a:ln>
-            <a:noFill/>
-          </a:ln>
-        </p:spPr>
-        <p:txBody>
-          <a:bodyPr spcFirstLastPara="1" wrap="square" lIns="91425" tIns="91425" rIns="91425" bIns="91425" anchor="t" anchorCtr="0">
-            <a:spAutoFit/>
-          </a:bodyPr>
-          <a:lstStyle/>
-          <a:p>
-            <a:pPr marL="0" lvl="0" indent="0" algn="l" rtl="0">
-              <a:spcBef>
-                <a:spcPts val="0"/>
-              </a:spcBef>
-              <a:spcAft>
-                <a:spcPts val="0"/>
-              </a:spcAft>
-              <a:buNone/>
-            </a:pPr>
-            <a:r>
-              <a:rPr lang="en-GB" sz="900" dirty="0">
-                <a:solidFill>
-                  <a:schemeClr val="dk2"/>
-                </a:solidFill>
-              </a:rPr>
-              <a:t>Schematics</a:t>
-            </a:r>
-            <a:endParaRPr sz="900" dirty="0">
-              <a:solidFill>
-                <a:schemeClr val="dk2"/>
-              </a:solidFill>
-            </a:endParaRPr>
-          </a:p>
-        </p:txBody>
-      </p:sp>
-      <p:sp>
-        <p:nvSpPr>
-          <p:cNvPr id="10" name="Google Shape;224;p30">
-            <a:extLst>
-              <a:ext uri="{FF2B5EF4-FFF2-40B4-BE49-F238E27FC236}">
-                <a16:creationId xmlns:a16="http://schemas.microsoft.com/office/drawing/2014/main" id="{D0AD3E50-2C12-4E0D-BDD9-B84D4029A6E0}"/>
-              </a:ext>
-            </a:extLst>
-          </p:cNvPr>
-          <p:cNvSpPr txBox="1"/>
-          <p:nvPr/>
-        </p:nvSpPr>
-        <p:spPr>
-          <a:xfrm>
-            <a:off x="0" y="0"/>
-            <a:ext cx="1662900" cy="266100"/>
-          </a:xfrm>
-          <a:prstGeom prst="rect">
-            <a:avLst/>
-          </a:prstGeom>
-          <a:noFill/>
-          <a:ln>
-            <a:noFill/>
-          </a:ln>
-        </p:spPr>
-        <p:txBody>
-          <a:bodyPr spcFirstLastPara="1" wrap="square" lIns="91425" tIns="91425" rIns="91425" bIns="91425" anchor="t" anchorCtr="0">
-            <a:noAutofit/>
-          </a:bodyPr>
-          <a:lstStyle/>
-          <a:p>
-            <a:pPr marL="0" lvl="0" indent="0" algn="l" rtl="0">
-              <a:spcBef>
-                <a:spcPts val="0"/>
-              </a:spcBef>
-              <a:spcAft>
-                <a:spcPts val="0"/>
-              </a:spcAft>
-              <a:buNone/>
-            </a:pPr>
-            <a:r>
-              <a:rPr lang="en-GB" sz="800">
-                <a:solidFill>
-                  <a:schemeClr val="dk2"/>
-                </a:solidFill>
-              </a:rPr>
-              <a:t>Hardware Engineering Lab</a:t>
-            </a:r>
-            <a:endParaRPr sz="800">
-              <a:solidFill>
-                <a:schemeClr val="dk2"/>
-              </a:solidFill>
-            </a:endParaRPr>
-          </a:p>
-        </p:txBody>
-      </p:sp>
-      <p:sp>
-        <p:nvSpPr>
-          <p:cNvPr id="11" name="Google Shape;225;p30">
-            <a:extLst>
-              <a:ext uri="{FF2B5EF4-FFF2-40B4-BE49-F238E27FC236}">
-                <a16:creationId xmlns:a16="http://schemas.microsoft.com/office/drawing/2014/main" id="{88E39909-C97E-4124-890B-D1E9BB53D593}"/>
-              </a:ext>
-            </a:extLst>
-          </p:cNvPr>
-          <p:cNvSpPr txBox="1"/>
-          <p:nvPr/>
-        </p:nvSpPr>
-        <p:spPr>
-          <a:xfrm>
-            <a:off x="7481100" y="0"/>
-            <a:ext cx="1662900" cy="266100"/>
-          </a:xfrm>
-          <a:prstGeom prst="rect">
-            <a:avLst/>
-          </a:prstGeom>
-          <a:noFill/>
-          <a:ln>
-            <a:noFill/>
-          </a:ln>
-        </p:spPr>
-        <p:txBody>
-          <a:bodyPr spcFirstLastPara="1" wrap="square" lIns="91425" tIns="91425" rIns="91425" bIns="91425" anchor="t" anchorCtr="0">
-            <a:noAutofit/>
-          </a:bodyPr>
-          <a:lstStyle/>
-          <a:p>
-            <a:pPr marL="0" lvl="0" indent="0" algn="r" rtl="0">
-              <a:spcBef>
-                <a:spcPts val="0"/>
-              </a:spcBef>
-              <a:spcAft>
-                <a:spcPts val="0"/>
-              </a:spcAft>
-              <a:buNone/>
-            </a:pPr>
-            <a:r>
-              <a:rPr lang="en-GB" sz="800">
-                <a:solidFill>
-                  <a:schemeClr val="dk2"/>
-                </a:solidFill>
-              </a:rPr>
-              <a:t>Summer Term 2025</a:t>
-            </a:r>
-            <a:endParaRPr sz="800">
-              <a:solidFill>
-                <a:schemeClr val="dk2"/>
-              </a:solidFill>
-            </a:endParaRPr>
-          </a:p>
-        </p:txBody>
-      </p:sp>
     </p:spTree>
   </p:cSld>
   <p:clrMapOvr>
@@ -12052,10 +11720,10 @@
               <a:buNone/>
             </a:pPr>
             <a:r>
-              <a:rPr lang="en-GB"/>
-              <a:t>Concepts with diagrams_block diagram</a:t>
-            </a:r>
-            <a:endParaRPr/>
+              <a:rPr lang="en-GB" dirty="0"/>
+              <a:t>Requirements and Functionalities</a:t>
+            </a:r>
+            <a:endParaRPr dirty="0"/>
           </a:p>
         </p:txBody>
       </p:sp>
@@ -12184,24 +11852,16 @@
           </a:bodyPr>
           <a:lstStyle/>
           <a:p>
-            <a:pPr marL="0" lvl="0" indent="0" algn="ctr" rtl="0">
-              <a:spcBef>
-                <a:spcPts val="0"/>
-              </a:spcBef>
-              <a:spcAft>
-                <a:spcPts val="0"/>
-              </a:spcAft>
-              <a:buNone/>
-            </a:pPr>
-            <a:r>
-              <a:rPr lang="en-GB" sz="800">
+            <a:pPr lvl="0" algn="ctr"/>
+            <a:r>
+              <a:rPr lang="en-GB" sz="800" dirty="0">
                 <a:solidFill>
                   <a:schemeClr val="dk2"/>
                 </a:solidFill>
               </a:rPr>
-              <a:t>Page 2</a:t>
-            </a:r>
-            <a:endParaRPr sz="800">
+              <a:t>Page 2 : presenter Emaan</a:t>
+            </a:r>
+            <a:endParaRPr sz="800" dirty="0">
               <a:solidFill>
                 <a:schemeClr val="dk2"/>
               </a:solidFill>
@@ -12209,9 +11869,629 @@
           </a:p>
         </p:txBody>
       </p:sp>
+      <p:sp>
+        <p:nvSpPr>
+          <p:cNvPr id="2" name="Rectangle 1">
+            <a:extLst>
+              <a:ext uri="{FF2B5EF4-FFF2-40B4-BE49-F238E27FC236}">
+                <a16:creationId xmlns:a16="http://schemas.microsoft.com/office/drawing/2014/main" id="{825B2D6C-8292-4F24-9069-C77DEE64E7C3}"/>
+              </a:ext>
+            </a:extLst>
+          </p:cNvPr>
+          <p:cNvSpPr/>
+          <p:nvPr/>
+        </p:nvSpPr>
+        <p:spPr>
+          <a:xfrm>
+            <a:off x="118142" y="1343035"/>
+            <a:ext cx="6476218" cy="3534365"/>
+          </a:xfrm>
+          <a:prstGeom prst="rect">
+            <a:avLst/>
+          </a:prstGeom>
+          <a:solidFill>
+            <a:schemeClr val="bg1"/>
+          </a:solidFill>
+        </p:spPr>
+        <p:txBody>
+          <a:bodyPr wrap="square">
+            <a:spAutoFit/>
+          </a:bodyPr>
+          <a:lstStyle/>
+          <a:p>
+            <a:pPr lvl="0" fontAlgn="base">
+              <a:lnSpc>
+                <a:spcPct val="107000"/>
+              </a:lnSpc>
+              <a:spcAft>
+                <a:spcPts val="0"/>
+              </a:spcAft>
+              <a:buSzPts val="1000"/>
+              <a:tabLst>
+                <a:tab pos="457200" algn="l"/>
+              </a:tabLst>
+            </a:pPr>
+            <a:r>
+              <a:rPr lang="en-US" sz="1400" dirty="0"/>
+              <a:t>We started our project by formulating what functionalities we would like to achieve with this project. The goal of the project was to design and implement a fully functional vending machine controller using an FPGA, with a modular VHDL architecture, then later on design a custom PCB prototype.</a:t>
+            </a:r>
+          </a:p>
+          <a:p>
+            <a:pPr lvl="0" fontAlgn="base">
+              <a:lnSpc>
+                <a:spcPct val="107000"/>
+              </a:lnSpc>
+              <a:spcAft>
+                <a:spcPts val="0"/>
+              </a:spcAft>
+              <a:buSzPts val="1000"/>
+              <a:tabLst>
+                <a:tab pos="457200" algn="l"/>
+              </a:tabLst>
+            </a:pPr>
+            <a:endParaRPr lang="en-US" sz="1400" dirty="0"/>
+          </a:p>
+          <a:p>
+            <a:pPr lvl="0" fontAlgn="base">
+              <a:lnSpc>
+                <a:spcPct val="107000"/>
+              </a:lnSpc>
+              <a:spcAft>
+                <a:spcPts val="0"/>
+              </a:spcAft>
+              <a:buSzPts val="1000"/>
+              <a:tabLst>
+                <a:tab pos="457200" algn="l"/>
+              </a:tabLst>
+            </a:pPr>
+            <a:r>
+              <a:rPr lang="en-US" sz="1400" dirty="0"/>
+              <a:t>The key functionalities/requirements of the vending machine was the following. </a:t>
+            </a:r>
+          </a:p>
+          <a:p>
+            <a:pPr lvl="0" fontAlgn="base">
+              <a:lnSpc>
+                <a:spcPct val="107000"/>
+              </a:lnSpc>
+              <a:spcAft>
+                <a:spcPts val="0"/>
+              </a:spcAft>
+              <a:buSzPts val="1000"/>
+              <a:tabLst>
+                <a:tab pos="457200" algn="l"/>
+              </a:tabLst>
+            </a:pPr>
+            <a:endParaRPr lang="en-US" sz="1400" dirty="0"/>
+          </a:p>
+          <a:p>
+            <a:pPr marL="342900" lvl="0" indent="-342900" fontAlgn="base">
+              <a:lnSpc>
+                <a:spcPct val="107000"/>
+              </a:lnSpc>
+              <a:spcAft>
+                <a:spcPts val="0"/>
+              </a:spcAft>
+              <a:buSzPts val="1000"/>
+              <a:buFont typeface="Symbol" panose="05050102010706020507" pitchFamily="18" charset="2"/>
+              <a:buChar char=""/>
+              <a:tabLst>
+                <a:tab pos="457200" algn="l"/>
+              </a:tabLst>
+            </a:pPr>
+            <a:r>
+              <a:rPr lang="en-US" sz="1400" dirty="0"/>
+              <a:t>Selection of items using switches</a:t>
+            </a:r>
+          </a:p>
+          <a:p>
+            <a:pPr marL="342900" lvl="0" indent="-342900" fontAlgn="base">
+              <a:lnSpc>
+                <a:spcPct val="107000"/>
+              </a:lnSpc>
+              <a:spcAft>
+                <a:spcPts val="0"/>
+              </a:spcAft>
+              <a:buSzPts val="1000"/>
+              <a:buFont typeface="Symbol" panose="05050102010706020507" pitchFamily="18" charset="2"/>
+              <a:buChar char=""/>
+              <a:tabLst>
+                <a:tab pos="457200" algn="l"/>
+              </a:tabLst>
+            </a:pPr>
+            <a:r>
+              <a:rPr lang="en-US" sz="1400" dirty="0"/>
+              <a:t>Display the names and the prices of the items using 8 digits of seven segment display</a:t>
+            </a:r>
+          </a:p>
+          <a:p>
+            <a:pPr marL="342900" lvl="0" indent="-342900" fontAlgn="base">
+              <a:lnSpc>
+                <a:spcPct val="107000"/>
+              </a:lnSpc>
+              <a:spcAft>
+                <a:spcPts val="0"/>
+              </a:spcAft>
+              <a:buSzPts val="1000"/>
+              <a:buFont typeface="Symbol" panose="05050102010706020507" pitchFamily="18" charset="2"/>
+              <a:buChar char=""/>
+              <a:tabLst>
+                <a:tab pos="457200" algn="l"/>
+              </a:tabLst>
+            </a:pPr>
+            <a:r>
+              <a:rPr lang="en-US" sz="1400" dirty="0"/>
+              <a:t>Insertion coins using push buttons</a:t>
+            </a:r>
+          </a:p>
+          <a:p>
+            <a:pPr marL="342900" lvl="0" indent="-342900" fontAlgn="base">
+              <a:lnSpc>
+                <a:spcPct val="107000"/>
+              </a:lnSpc>
+              <a:spcAft>
+                <a:spcPts val="0"/>
+              </a:spcAft>
+              <a:buSzPts val="1000"/>
+              <a:buFont typeface="Symbol" panose="05050102010706020507" pitchFamily="18" charset="2"/>
+              <a:buChar char=""/>
+              <a:tabLst>
+                <a:tab pos="457200" algn="l"/>
+              </a:tabLst>
+            </a:pPr>
+            <a:r>
+              <a:rPr lang="en-US" sz="1400" dirty="0"/>
+              <a:t>Display the inserted coin amounts using 8 digits of seven segment display</a:t>
+            </a:r>
+          </a:p>
+          <a:p>
+            <a:pPr marL="342900" lvl="0" indent="-342900" fontAlgn="base">
+              <a:lnSpc>
+                <a:spcPct val="107000"/>
+              </a:lnSpc>
+              <a:spcAft>
+                <a:spcPts val="1000"/>
+              </a:spcAft>
+              <a:buSzPts val="1000"/>
+              <a:buFont typeface="Symbol" panose="05050102010706020507" pitchFamily="18" charset="2"/>
+              <a:buChar char=""/>
+              <a:tabLst>
+                <a:tab pos="457200" algn="l"/>
+              </a:tabLst>
+            </a:pPr>
+            <a:r>
+              <a:rPr lang="en-US" sz="1400" dirty="0"/>
+              <a:t>Display the current state using LEDs</a:t>
+            </a:r>
+          </a:p>
+        </p:txBody>
+      </p:sp>
       <p:pic>
         <p:nvPicPr>
-          <p:cNvPr id="68" name="Google Shape;68;p14"/>
+          <p:cNvPr id="2052" name="Picture 4" descr="Vending Machine Filled Line Icon Grafik Von Mahi Icons · Creative Fabrica">
+            <a:extLst>
+              <a:ext uri="{FF2B5EF4-FFF2-40B4-BE49-F238E27FC236}">
+                <a16:creationId xmlns:a16="http://schemas.microsoft.com/office/drawing/2014/main" id="{2BCCC032-A2E6-492B-B40E-EF094A841249}"/>
+              </a:ext>
+            </a:extLst>
+          </p:cNvPr>
+          <p:cNvPicPr>
+            <a:picLocks noChangeAspect="1" noChangeArrowheads="1"/>
+          </p:cNvPicPr>
+          <p:nvPr/>
+        </p:nvPicPr>
+        <p:blipFill rotWithShape="1">
+          <a:blip r:embed="rId3">
+            <a:extLst>
+              <a:ext uri="{28A0092B-C50C-407E-A947-70E740481C1C}">
+                <a14:useLocalDpi xmlns:a14="http://schemas.microsoft.com/office/drawing/2010/main" val="0"/>
+              </a:ext>
+            </a:extLst>
+          </a:blip>
+          <a:srcRect l="29584" t="5173" r="29064" b="5173"/>
+          <a:stretch/>
+        </p:blipFill>
+        <p:spPr bwMode="auto">
+          <a:xfrm>
+            <a:off x="6701151" y="1481728"/>
+            <a:ext cx="1998387" cy="2888413"/>
+          </a:xfrm>
+          <a:prstGeom prst="rect">
+            <a:avLst/>
+          </a:prstGeom>
+          <a:noFill/>
+          <a:extLst>
+            <a:ext uri="{909E8E84-426E-40DD-AFC4-6F175D3DCCD1}">
+              <a14:hiddenFill xmlns:a14="http://schemas.microsoft.com/office/drawing/2010/main">
+                <a:solidFill>
+                  <a:srgbClr val="FFFFFF"/>
+                </a:solidFill>
+              </a14:hiddenFill>
+            </a:ext>
+          </a:extLst>
+        </p:spPr>
+      </p:pic>
+    </p:spTree>
+  </p:cSld>
+  <p:clrMapOvr>
+    <a:masterClrMapping/>
+  </p:clrMapOvr>
+</p:sld>
+</file>
+
+<file path=ppt/slides/slide20.xml><?xml version="1.0" encoding="utf-8"?>
+<p:sld xmlns:a="http://schemas.openxmlformats.org/drawingml/2006/main" xmlns:r="http://schemas.openxmlformats.org/officeDocument/2006/relationships" xmlns:p="http://schemas.openxmlformats.org/presentationml/2006/main">
+  <p:cSld>
+    <p:spTree>
+      <p:nvGrpSpPr>
+        <p:cNvPr id="1" name="Shape 231"/>
+        <p:cNvGrpSpPr/>
+        <p:nvPr/>
+      </p:nvGrpSpPr>
+      <p:grpSpPr>
+        <a:xfrm>
+          <a:off x="0" y="0"/>
+          <a:ext cx="0" cy="0"/>
+          <a:chOff x="0" y="0"/>
+          <a:chExt cx="0" cy="0"/>
+        </a:xfrm>
+      </p:grpSpPr>
+      <p:sp>
+        <p:nvSpPr>
+          <p:cNvPr id="232" name="Google Shape;232;p31"/>
+          <p:cNvSpPr txBox="1">
+            <a:spLocks noGrp="1"/>
+          </p:cNvSpPr>
+          <p:nvPr>
+            <p:ph type="title"/>
+          </p:nvPr>
+        </p:nvSpPr>
+        <p:spPr>
+          <a:prstGeom prst="rect">
+            <a:avLst/>
+          </a:prstGeom>
+        </p:spPr>
+        <p:txBody>
+          <a:bodyPr spcFirstLastPara="1" wrap="square" lIns="91425" tIns="91425" rIns="91425" bIns="91425" anchor="t" anchorCtr="0">
+            <a:normAutofit fontScale="90000"/>
+          </a:bodyPr>
+          <a:lstStyle/>
+          <a:p>
+            <a:pPr marL="0" lvl="0" indent="0" algn="l" rtl="0">
+              <a:spcBef>
+                <a:spcPts val="0"/>
+              </a:spcBef>
+              <a:spcAft>
+                <a:spcPts val="0"/>
+              </a:spcAft>
+              <a:buNone/>
+            </a:pPr>
+            <a:r>
+              <a:rPr lang="en-GB"/>
+              <a:t>PCB Prototyping</a:t>
+            </a:r>
+            <a:endParaRPr/>
+          </a:p>
+        </p:txBody>
+      </p:sp>
+      <p:sp>
+        <p:nvSpPr>
+          <p:cNvPr id="233" name="Google Shape;233;p31"/>
+          <p:cNvSpPr txBox="1">
+            <a:spLocks noGrp="1"/>
+          </p:cNvSpPr>
+          <p:nvPr>
+            <p:ph type="body" idx="1"/>
+          </p:nvPr>
+        </p:nvSpPr>
+        <p:spPr>
+          <a:xfrm>
+            <a:off x="311699" y="1152475"/>
+            <a:ext cx="3600061" cy="3459600"/>
+          </a:xfrm>
+          <a:prstGeom prst="rect">
+            <a:avLst/>
+          </a:prstGeom>
+        </p:spPr>
+        <p:txBody>
+          <a:bodyPr spcFirstLastPara="1" wrap="square" lIns="91425" tIns="91425" rIns="91425" bIns="91425" anchor="t" anchorCtr="0">
+            <a:normAutofit/>
+          </a:bodyPr>
+          <a:lstStyle/>
+          <a:p>
+            <a:pPr marL="0" lvl="0" indent="0" algn="l" rtl="0">
+              <a:spcBef>
+                <a:spcPts val="0"/>
+              </a:spcBef>
+              <a:spcAft>
+                <a:spcPts val="0"/>
+              </a:spcAft>
+              <a:buNone/>
+            </a:pPr>
+            <a:r>
+              <a:rPr lang="en-GB" sz="1100" dirty="0">
+                <a:solidFill>
+                  <a:schemeClr val="dk1"/>
+                </a:solidFill>
+              </a:rPr>
+              <a:t>After discussion and deep analysis we select these elements for our PCB </a:t>
+            </a:r>
+            <a:endParaRPr sz="1100" dirty="0">
+              <a:solidFill>
+                <a:schemeClr val="dk1"/>
+              </a:solidFill>
+            </a:endParaRPr>
+          </a:p>
+          <a:p>
+            <a:pPr marL="457200" lvl="0" indent="-298450" algn="l" rtl="0">
+              <a:lnSpc>
+                <a:spcPct val="100000"/>
+              </a:lnSpc>
+              <a:spcBef>
+                <a:spcPts val="1200"/>
+              </a:spcBef>
+              <a:spcAft>
+                <a:spcPts val="0"/>
+              </a:spcAft>
+              <a:buClr>
+                <a:schemeClr val="dk1"/>
+              </a:buClr>
+              <a:buSzPts val="1100"/>
+              <a:buChar char="●"/>
+            </a:pPr>
+            <a:r>
+              <a:rPr lang="en-GB" sz="1100" dirty="0">
+                <a:solidFill>
+                  <a:schemeClr val="dk1"/>
+                </a:solidFill>
+              </a:rPr>
+              <a:t>Two 7 segment display</a:t>
+            </a:r>
+          </a:p>
+          <a:p>
+            <a:pPr marL="457200" lvl="0" indent="-298450" algn="l" rtl="0">
+              <a:lnSpc>
+                <a:spcPct val="100000"/>
+              </a:lnSpc>
+              <a:spcBef>
+                <a:spcPts val="1200"/>
+              </a:spcBef>
+              <a:spcAft>
+                <a:spcPts val="0"/>
+              </a:spcAft>
+              <a:buClr>
+                <a:schemeClr val="dk1"/>
+              </a:buClr>
+              <a:buSzPts val="1100"/>
+              <a:buChar char="●"/>
+            </a:pPr>
+            <a:endParaRPr sz="1100" dirty="0">
+              <a:solidFill>
+                <a:schemeClr val="dk1"/>
+              </a:solidFill>
+            </a:endParaRPr>
+          </a:p>
+          <a:p>
+            <a:pPr marL="457200" lvl="0" indent="-298450" algn="l" rtl="0">
+              <a:spcBef>
+                <a:spcPts val="0"/>
+              </a:spcBef>
+              <a:spcAft>
+                <a:spcPts val="0"/>
+              </a:spcAft>
+              <a:buClr>
+                <a:schemeClr val="dk1"/>
+              </a:buClr>
+              <a:buSzPts val="1100"/>
+              <a:buChar char="●"/>
+            </a:pPr>
+            <a:r>
+              <a:rPr lang="en-GB" sz="1100" dirty="0">
+                <a:solidFill>
+                  <a:schemeClr val="dk1"/>
+                </a:solidFill>
+              </a:rPr>
+              <a:t>Power supply</a:t>
+            </a:r>
+          </a:p>
+          <a:p>
+            <a:pPr marL="457200" lvl="0" indent="-298450" algn="l" rtl="0">
+              <a:spcBef>
+                <a:spcPts val="0"/>
+              </a:spcBef>
+              <a:spcAft>
+                <a:spcPts val="0"/>
+              </a:spcAft>
+              <a:buClr>
+                <a:schemeClr val="dk1"/>
+              </a:buClr>
+              <a:buSzPts val="1100"/>
+              <a:buChar char="●"/>
+            </a:pPr>
+            <a:endParaRPr sz="1100" dirty="0">
+              <a:solidFill>
+                <a:schemeClr val="dk1"/>
+              </a:solidFill>
+            </a:endParaRPr>
+          </a:p>
+          <a:p>
+            <a:pPr marL="457200" lvl="0" indent="-298450" algn="l" rtl="0">
+              <a:spcBef>
+                <a:spcPts val="0"/>
+              </a:spcBef>
+              <a:spcAft>
+                <a:spcPts val="0"/>
+              </a:spcAft>
+              <a:buClr>
+                <a:schemeClr val="dk1"/>
+              </a:buClr>
+              <a:buSzPts val="1100"/>
+              <a:buChar char="●"/>
+            </a:pPr>
+            <a:r>
+              <a:rPr lang="en-GB" sz="1100" dirty="0">
+                <a:solidFill>
+                  <a:schemeClr val="dk1"/>
+                </a:solidFill>
+              </a:rPr>
+              <a:t>Resistors and Capacitors</a:t>
+            </a:r>
+          </a:p>
+          <a:p>
+            <a:pPr marL="457200" lvl="0" indent="-298450" algn="l" rtl="0">
+              <a:spcBef>
+                <a:spcPts val="0"/>
+              </a:spcBef>
+              <a:spcAft>
+                <a:spcPts val="0"/>
+              </a:spcAft>
+              <a:buClr>
+                <a:schemeClr val="dk1"/>
+              </a:buClr>
+              <a:buSzPts val="1100"/>
+              <a:buChar char="●"/>
+            </a:pPr>
+            <a:endParaRPr sz="1100" dirty="0">
+              <a:solidFill>
+                <a:schemeClr val="dk1"/>
+              </a:solidFill>
+            </a:endParaRPr>
+          </a:p>
+          <a:p>
+            <a:pPr marL="457200" lvl="0" indent="-298450" algn="l" rtl="0">
+              <a:spcBef>
+                <a:spcPts val="0"/>
+              </a:spcBef>
+              <a:spcAft>
+                <a:spcPts val="0"/>
+              </a:spcAft>
+              <a:buClr>
+                <a:schemeClr val="dk1"/>
+              </a:buClr>
+              <a:buSzPts val="1100"/>
+              <a:buChar char="●"/>
+            </a:pPr>
+            <a:r>
+              <a:rPr lang="en-GB" sz="1100" dirty="0">
+                <a:solidFill>
+                  <a:schemeClr val="dk1"/>
+                </a:solidFill>
+              </a:rPr>
+              <a:t>Central component is the Nexus A7 </a:t>
+            </a:r>
+            <a:r>
+              <a:rPr lang="en-GB" sz="1100" i="1" dirty="0">
+                <a:solidFill>
+                  <a:schemeClr val="dk1"/>
+                </a:solidFill>
+              </a:rPr>
+              <a:t>XC7A100T </a:t>
+            </a:r>
+            <a:r>
+              <a:rPr lang="en-GB" sz="1100" dirty="0">
+                <a:solidFill>
+                  <a:schemeClr val="dk1"/>
+                </a:solidFill>
+              </a:rPr>
+              <a:t>FPGA, handling all control logic and I/O</a:t>
+            </a:r>
+          </a:p>
+          <a:p>
+            <a:pPr marL="457200" lvl="0" indent="-298450" algn="l" rtl="0">
+              <a:spcBef>
+                <a:spcPts val="0"/>
+              </a:spcBef>
+              <a:spcAft>
+                <a:spcPts val="0"/>
+              </a:spcAft>
+              <a:buClr>
+                <a:schemeClr val="dk1"/>
+              </a:buClr>
+              <a:buSzPts val="1100"/>
+              <a:buChar char="●"/>
+            </a:pPr>
+            <a:endParaRPr sz="1100" dirty="0">
+              <a:solidFill>
+                <a:schemeClr val="dk1"/>
+              </a:solidFill>
+            </a:endParaRPr>
+          </a:p>
+          <a:p>
+            <a:pPr marL="457200" lvl="0" indent="-298450" algn="l" rtl="0">
+              <a:spcBef>
+                <a:spcPts val="0"/>
+              </a:spcBef>
+              <a:spcAft>
+                <a:spcPts val="0"/>
+              </a:spcAft>
+              <a:buClr>
+                <a:schemeClr val="dk1"/>
+              </a:buClr>
+              <a:buSzPts val="1100"/>
+              <a:buChar char="●"/>
+            </a:pPr>
+            <a:r>
+              <a:rPr lang="en-GB" sz="1100" dirty="0">
+                <a:solidFill>
+                  <a:schemeClr val="dk1"/>
+                </a:solidFill>
+              </a:rPr>
+              <a:t>Connected to multiple push buttons for item selection and user interaction.</a:t>
+            </a:r>
+          </a:p>
+          <a:p>
+            <a:pPr marL="457200" lvl="0" indent="-298450" algn="l" rtl="0">
+              <a:spcBef>
+                <a:spcPts val="0"/>
+              </a:spcBef>
+              <a:spcAft>
+                <a:spcPts val="0"/>
+              </a:spcAft>
+              <a:buClr>
+                <a:schemeClr val="dk1"/>
+              </a:buClr>
+              <a:buSzPts val="1100"/>
+              <a:buChar char="●"/>
+            </a:pPr>
+            <a:endParaRPr sz="1100" dirty="0">
+              <a:solidFill>
+                <a:schemeClr val="dk1"/>
+              </a:solidFill>
+            </a:endParaRPr>
+          </a:p>
+          <a:p>
+            <a:pPr marL="457200" lvl="0" indent="-298450" algn="l" rtl="0">
+              <a:spcBef>
+                <a:spcPts val="0"/>
+              </a:spcBef>
+              <a:spcAft>
+                <a:spcPts val="0"/>
+              </a:spcAft>
+              <a:buClr>
+                <a:schemeClr val="dk1"/>
+              </a:buClr>
+              <a:buSzPts val="1100"/>
+              <a:buChar char="●"/>
+            </a:pPr>
+            <a:r>
+              <a:rPr lang="en-GB" sz="1100" b="1" dirty="0">
+                <a:solidFill>
+                  <a:schemeClr val="dk1"/>
+                </a:solidFill>
+              </a:rPr>
+              <a:t>PNP and NPN transistors control outputs like relays or motors, acting as switches via FPGA signals.</a:t>
+            </a:r>
+            <a:endParaRPr sz="1100" b="1" dirty="0">
+              <a:solidFill>
+                <a:schemeClr val="dk1"/>
+              </a:solidFill>
+            </a:endParaRPr>
+          </a:p>
+        </p:txBody>
+      </p:sp>
+      <p:pic>
+        <p:nvPicPr>
+          <p:cNvPr id="234" name="Google Shape;234;p31"/>
           <p:cNvPicPr preferRelativeResize="0"/>
           <p:nvPr/>
         </p:nvPicPr>
@@ -12225,8 +12505,8 @@
         </p:blipFill>
         <p:spPr>
           <a:xfrm>
-            <a:off x="145000" y="1051900"/>
-            <a:ext cx="5846127" cy="3685151"/>
+            <a:off x="3978662" y="244902"/>
+            <a:ext cx="4724824" cy="3003451"/>
           </a:xfrm>
           <a:prstGeom prst="rect">
             <a:avLst/>
@@ -12237,140 +12517,9 @@
           </a:ln>
         </p:spPr>
       </p:pic>
-      <p:sp>
-        <p:nvSpPr>
-          <p:cNvPr id="2" name="Rectangle 1">
-            <a:extLst>
-              <a:ext uri="{FF2B5EF4-FFF2-40B4-BE49-F238E27FC236}">
-                <a16:creationId xmlns:a16="http://schemas.microsoft.com/office/drawing/2014/main" id="{825B2D6C-8292-4F24-9069-C77DEE64E7C3}"/>
-              </a:ext>
-            </a:extLst>
-          </p:cNvPr>
-          <p:cNvSpPr/>
-          <p:nvPr/>
-        </p:nvSpPr>
-        <p:spPr>
-          <a:xfrm>
-            <a:off x="5991127" y="1357804"/>
-            <a:ext cx="3017300" cy="3073342"/>
-          </a:xfrm>
-          <a:prstGeom prst="rect">
-            <a:avLst/>
-          </a:prstGeom>
-          <a:solidFill>
-            <a:schemeClr val="bg1"/>
-          </a:solidFill>
-        </p:spPr>
-        <p:txBody>
-          <a:bodyPr wrap="square">
-            <a:spAutoFit/>
-          </a:bodyPr>
-          <a:lstStyle/>
-          <a:p>
-            <a:pPr marL="342900" lvl="0" indent="-342900" fontAlgn="base">
-              <a:lnSpc>
-                <a:spcPct val="107000"/>
-              </a:lnSpc>
-              <a:spcAft>
-                <a:spcPts val="0"/>
-              </a:spcAft>
-              <a:buSzPts val="1000"/>
-              <a:buFont typeface="Symbol" panose="05050102010706020507" pitchFamily="18" charset="2"/>
-              <a:buChar char=""/>
-              <a:tabLst>
-                <a:tab pos="457200" algn="l"/>
-              </a:tabLst>
-            </a:pPr>
-            <a:r>
-              <a:rPr lang="en-US" sz="1400" dirty="0"/>
-              <a:t>Selection of items using switches</a:t>
-            </a:r>
-          </a:p>
-          <a:p>
-            <a:pPr marL="342900" lvl="0" indent="-342900" fontAlgn="base">
-              <a:lnSpc>
-                <a:spcPct val="107000"/>
-              </a:lnSpc>
-              <a:spcAft>
-                <a:spcPts val="0"/>
-              </a:spcAft>
-              <a:buSzPts val="1000"/>
-              <a:buFont typeface="Symbol" panose="05050102010706020507" pitchFamily="18" charset="2"/>
-              <a:buChar char=""/>
-              <a:tabLst>
-                <a:tab pos="457200" algn="l"/>
-              </a:tabLst>
-            </a:pPr>
-            <a:r>
-              <a:rPr lang="en-US" sz="1400" dirty="0"/>
-              <a:t>Display the names and the prices of the items using 8 digits of seven segment display</a:t>
-            </a:r>
-          </a:p>
-          <a:p>
-            <a:pPr marL="342900" lvl="0" indent="-342900" fontAlgn="base">
-              <a:lnSpc>
-                <a:spcPct val="107000"/>
-              </a:lnSpc>
-              <a:spcAft>
-                <a:spcPts val="0"/>
-              </a:spcAft>
-              <a:buSzPts val="1000"/>
-              <a:buFont typeface="Symbol" panose="05050102010706020507" pitchFamily="18" charset="2"/>
-              <a:buChar char=""/>
-              <a:tabLst>
-                <a:tab pos="457200" algn="l"/>
-              </a:tabLst>
-            </a:pPr>
-            <a:r>
-              <a:rPr lang="en-US" sz="1400" dirty="0"/>
-              <a:t>Insertion coins using push buttons</a:t>
-            </a:r>
-          </a:p>
-          <a:p>
-            <a:pPr marL="342900" lvl="0" indent="-342900" fontAlgn="base">
-              <a:lnSpc>
-                <a:spcPct val="107000"/>
-              </a:lnSpc>
-              <a:spcAft>
-                <a:spcPts val="0"/>
-              </a:spcAft>
-              <a:buSzPts val="1000"/>
-              <a:buFont typeface="Symbol" panose="05050102010706020507" pitchFamily="18" charset="2"/>
-              <a:buChar char=""/>
-              <a:tabLst>
-                <a:tab pos="457200" algn="l"/>
-              </a:tabLst>
-            </a:pPr>
-            <a:r>
-              <a:rPr lang="en-US" sz="1400" dirty="0"/>
-              <a:t>Display the inserted coin amounts using 8 digits of seven segment display</a:t>
-            </a:r>
-          </a:p>
-          <a:p>
-            <a:pPr marL="342900" lvl="0" indent="-342900" fontAlgn="base">
-              <a:lnSpc>
-                <a:spcPct val="107000"/>
-              </a:lnSpc>
-              <a:spcAft>
-                <a:spcPts val="1000"/>
-              </a:spcAft>
-              <a:buSzPts val="1000"/>
-              <a:buFont typeface="Symbol" panose="05050102010706020507" pitchFamily="18" charset="2"/>
-              <a:buChar char=""/>
-              <a:tabLst>
-                <a:tab pos="457200" algn="l"/>
-              </a:tabLst>
-            </a:pPr>
-            <a:r>
-              <a:rPr lang="en-US" sz="1400" dirty="0"/>
-              <a:t>Display the current state using LEDs</a:t>
-            </a:r>
-          </a:p>
-        </p:txBody>
-      </p:sp>
       <p:pic>
         <p:nvPicPr>
-          <p:cNvPr id="69" name="Google Shape;69;p14"/>
+          <p:cNvPr id="235" name="Google Shape;235;p31"/>
           <p:cNvPicPr preferRelativeResize="0"/>
           <p:nvPr/>
         </p:nvPicPr>
@@ -12383,9 +12532,9 @@
           </a:stretch>
         </p:blipFill>
         <p:spPr>
-          <a:xfrm>
-            <a:off x="5947967" y="1428775"/>
-            <a:ext cx="3103620" cy="2931399"/>
+          <a:xfrm rot="16200000">
+            <a:off x="5458361" y="3337500"/>
+            <a:ext cx="1604026" cy="1741874"/>
           </a:xfrm>
           <a:prstGeom prst="rect">
             <a:avLst/>
@@ -12396,90 +12545,331 @@
           </a:ln>
         </p:spPr>
       </p:pic>
+      <p:sp>
+        <p:nvSpPr>
+          <p:cNvPr id="236" name="Google Shape;236;p31"/>
+          <p:cNvSpPr txBox="1"/>
+          <p:nvPr/>
+        </p:nvSpPr>
+        <p:spPr>
+          <a:xfrm>
+            <a:off x="2375023" y="5568913"/>
+            <a:ext cx="1121700" cy="323100"/>
+          </a:xfrm>
+          <a:prstGeom prst="rect">
+            <a:avLst/>
+          </a:prstGeom>
+          <a:noFill/>
+          <a:ln>
+            <a:noFill/>
+          </a:ln>
+        </p:spPr>
+        <p:txBody>
+          <a:bodyPr spcFirstLastPara="1" wrap="square" lIns="91425" tIns="91425" rIns="91425" bIns="91425" anchor="t" anchorCtr="0">
+            <a:spAutoFit/>
+          </a:bodyPr>
+          <a:lstStyle/>
+          <a:p>
+            <a:pPr marL="0" lvl="0" indent="0" algn="l" rtl="0">
+              <a:spcBef>
+                <a:spcPts val="0"/>
+              </a:spcBef>
+              <a:spcAft>
+                <a:spcPts val="0"/>
+              </a:spcAft>
+              <a:buNone/>
+            </a:pPr>
+            <a:r>
+              <a:rPr lang="en-GB" sz="900" dirty="0">
+                <a:solidFill>
+                  <a:schemeClr val="dk2"/>
+                </a:solidFill>
+              </a:rPr>
+              <a:t>Schematics</a:t>
+            </a:r>
+            <a:endParaRPr sz="900" dirty="0">
+              <a:solidFill>
+                <a:schemeClr val="dk2"/>
+              </a:solidFill>
+            </a:endParaRPr>
+          </a:p>
+        </p:txBody>
+      </p:sp>
+      <p:sp>
+        <p:nvSpPr>
+          <p:cNvPr id="237" name="Google Shape;237;p31"/>
+          <p:cNvSpPr txBox="1"/>
+          <p:nvPr/>
+        </p:nvSpPr>
+        <p:spPr>
+          <a:xfrm>
+            <a:off x="7198213" y="4663801"/>
+            <a:ext cx="1121700" cy="323100"/>
+          </a:xfrm>
+          <a:prstGeom prst="rect">
+            <a:avLst/>
+          </a:prstGeom>
+          <a:noFill/>
+          <a:ln>
+            <a:noFill/>
+          </a:ln>
+        </p:spPr>
+        <p:txBody>
+          <a:bodyPr spcFirstLastPara="1" wrap="square" lIns="91425" tIns="91425" rIns="91425" bIns="91425" anchor="t" anchorCtr="0">
+            <a:spAutoFit/>
+          </a:bodyPr>
+          <a:lstStyle/>
+          <a:p>
+            <a:pPr marL="0" lvl="0" indent="0" algn="l" rtl="0">
+              <a:spcBef>
+                <a:spcPts val="0"/>
+              </a:spcBef>
+              <a:spcAft>
+                <a:spcPts val="0"/>
+              </a:spcAft>
+              <a:buNone/>
+            </a:pPr>
+            <a:r>
+              <a:rPr lang="en-GB" sz="900" dirty="0">
+                <a:solidFill>
+                  <a:schemeClr val="dk2"/>
+                </a:solidFill>
+              </a:rPr>
+              <a:t>3D View</a:t>
+            </a:r>
+            <a:endParaRPr sz="900" dirty="0">
+              <a:solidFill>
+                <a:schemeClr val="dk2"/>
+              </a:solidFill>
+            </a:endParaRPr>
+          </a:p>
+        </p:txBody>
+      </p:sp>
+      <p:sp>
+        <p:nvSpPr>
+          <p:cNvPr id="8" name="Google Shape;226;p30">
+            <a:extLst>
+              <a:ext uri="{FF2B5EF4-FFF2-40B4-BE49-F238E27FC236}">
+                <a16:creationId xmlns:a16="http://schemas.microsoft.com/office/drawing/2014/main" id="{D519478A-A558-4C1D-B352-7EBEE7A18BD9}"/>
+              </a:ext>
+            </a:extLst>
+          </p:cNvPr>
+          <p:cNvSpPr txBox="1"/>
+          <p:nvPr/>
+        </p:nvSpPr>
+        <p:spPr>
+          <a:xfrm>
+            <a:off x="3783275" y="4877400"/>
+            <a:ext cx="1662900" cy="266100"/>
+          </a:xfrm>
+          <a:prstGeom prst="rect">
+            <a:avLst/>
+          </a:prstGeom>
+          <a:noFill/>
+          <a:ln>
+            <a:noFill/>
+          </a:ln>
+        </p:spPr>
+        <p:txBody>
+          <a:bodyPr spcFirstLastPara="1" wrap="square" lIns="91425" tIns="91425" rIns="91425" bIns="91425" anchor="t" anchorCtr="0">
+            <a:noAutofit/>
+          </a:bodyPr>
+          <a:lstStyle/>
+          <a:p>
+            <a:pPr lvl="0" algn="ctr"/>
+            <a:r>
+              <a:rPr lang="en-GB" sz="800" dirty="0">
+                <a:solidFill>
+                  <a:schemeClr val="dk2"/>
+                </a:solidFill>
+              </a:rPr>
+              <a:t>Page 19 : presenter Emaan</a:t>
+            </a:r>
+            <a:endParaRPr sz="800" dirty="0">
+              <a:solidFill>
+                <a:schemeClr val="dk2"/>
+              </a:solidFill>
+            </a:endParaRPr>
+          </a:p>
+        </p:txBody>
+      </p:sp>
+      <p:sp>
+        <p:nvSpPr>
+          <p:cNvPr id="9" name="Google Shape;237;p31">
+            <a:extLst>
+              <a:ext uri="{FF2B5EF4-FFF2-40B4-BE49-F238E27FC236}">
+                <a16:creationId xmlns:a16="http://schemas.microsoft.com/office/drawing/2014/main" id="{A1BA26F8-BAC7-4F8C-9055-DA03B8999E59}"/>
+              </a:ext>
+            </a:extLst>
+          </p:cNvPr>
+          <p:cNvSpPr txBox="1"/>
+          <p:nvPr/>
+        </p:nvSpPr>
+        <p:spPr>
+          <a:xfrm>
+            <a:off x="7710600" y="3286926"/>
+            <a:ext cx="1121700" cy="323100"/>
+          </a:xfrm>
+          <a:prstGeom prst="rect">
+            <a:avLst/>
+          </a:prstGeom>
+          <a:noFill/>
+          <a:ln>
+            <a:noFill/>
+          </a:ln>
+        </p:spPr>
+        <p:txBody>
+          <a:bodyPr spcFirstLastPara="1" wrap="square" lIns="91425" tIns="91425" rIns="91425" bIns="91425" anchor="t" anchorCtr="0">
+            <a:spAutoFit/>
+          </a:bodyPr>
+          <a:lstStyle/>
+          <a:p>
+            <a:pPr marL="0" lvl="0" indent="0" algn="l" rtl="0">
+              <a:spcBef>
+                <a:spcPts val="0"/>
+              </a:spcBef>
+              <a:spcAft>
+                <a:spcPts val="0"/>
+              </a:spcAft>
+              <a:buNone/>
+            </a:pPr>
+            <a:r>
+              <a:rPr lang="en-GB" sz="900" dirty="0">
+                <a:solidFill>
+                  <a:schemeClr val="dk2"/>
+                </a:solidFill>
+              </a:rPr>
+              <a:t>Schematics</a:t>
+            </a:r>
+            <a:endParaRPr sz="900" dirty="0">
+              <a:solidFill>
+                <a:schemeClr val="dk2"/>
+              </a:solidFill>
+            </a:endParaRPr>
+          </a:p>
+        </p:txBody>
+      </p:sp>
+      <p:sp>
+        <p:nvSpPr>
+          <p:cNvPr id="10" name="Google Shape;224;p30">
+            <a:extLst>
+              <a:ext uri="{FF2B5EF4-FFF2-40B4-BE49-F238E27FC236}">
+                <a16:creationId xmlns:a16="http://schemas.microsoft.com/office/drawing/2014/main" id="{D0AD3E50-2C12-4E0D-BDD9-B84D4029A6E0}"/>
+              </a:ext>
+            </a:extLst>
+          </p:cNvPr>
+          <p:cNvSpPr txBox="1"/>
+          <p:nvPr/>
+        </p:nvSpPr>
+        <p:spPr>
+          <a:xfrm>
+            <a:off x="0" y="0"/>
+            <a:ext cx="1662900" cy="266100"/>
+          </a:xfrm>
+          <a:prstGeom prst="rect">
+            <a:avLst/>
+          </a:prstGeom>
+          <a:noFill/>
+          <a:ln>
+            <a:noFill/>
+          </a:ln>
+        </p:spPr>
+        <p:txBody>
+          <a:bodyPr spcFirstLastPara="1" wrap="square" lIns="91425" tIns="91425" rIns="91425" bIns="91425" anchor="t" anchorCtr="0">
+            <a:noAutofit/>
+          </a:bodyPr>
+          <a:lstStyle/>
+          <a:p>
+            <a:pPr marL="0" lvl="0" indent="0" algn="l" rtl="0">
+              <a:spcBef>
+                <a:spcPts val="0"/>
+              </a:spcBef>
+              <a:spcAft>
+                <a:spcPts val="0"/>
+              </a:spcAft>
+              <a:buNone/>
+            </a:pPr>
+            <a:r>
+              <a:rPr lang="en-GB" sz="800">
+                <a:solidFill>
+                  <a:schemeClr val="dk2"/>
+                </a:solidFill>
+              </a:rPr>
+              <a:t>Hardware Engineering Lab</a:t>
+            </a:r>
+            <a:endParaRPr sz="800">
+              <a:solidFill>
+                <a:schemeClr val="dk2"/>
+              </a:solidFill>
+            </a:endParaRPr>
+          </a:p>
+        </p:txBody>
+      </p:sp>
+      <p:sp>
+        <p:nvSpPr>
+          <p:cNvPr id="11" name="Google Shape;225;p30">
+            <a:extLst>
+              <a:ext uri="{FF2B5EF4-FFF2-40B4-BE49-F238E27FC236}">
+                <a16:creationId xmlns:a16="http://schemas.microsoft.com/office/drawing/2014/main" id="{88E39909-C97E-4124-890B-D1E9BB53D593}"/>
+              </a:ext>
+            </a:extLst>
+          </p:cNvPr>
+          <p:cNvSpPr txBox="1"/>
+          <p:nvPr/>
+        </p:nvSpPr>
+        <p:spPr>
+          <a:xfrm>
+            <a:off x="7481100" y="0"/>
+            <a:ext cx="1662900" cy="266100"/>
+          </a:xfrm>
+          <a:prstGeom prst="rect">
+            <a:avLst/>
+          </a:prstGeom>
+          <a:noFill/>
+          <a:ln>
+            <a:noFill/>
+          </a:ln>
+        </p:spPr>
+        <p:txBody>
+          <a:bodyPr spcFirstLastPara="1" wrap="square" lIns="91425" tIns="91425" rIns="91425" bIns="91425" anchor="t" anchorCtr="0">
+            <a:noAutofit/>
+          </a:bodyPr>
+          <a:lstStyle/>
+          <a:p>
+            <a:pPr marL="0" lvl="0" indent="0" algn="r" rtl="0">
+              <a:spcBef>
+                <a:spcPts val="0"/>
+              </a:spcBef>
+              <a:spcAft>
+                <a:spcPts val="0"/>
+              </a:spcAft>
+              <a:buNone/>
+            </a:pPr>
+            <a:r>
+              <a:rPr lang="en-GB" sz="800">
+                <a:solidFill>
+                  <a:schemeClr val="dk2"/>
+                </a:solidFill>
+              </a:rPr>
+              <a:t>Summer Term 2025</a:t>
+            </a:r>
+            <a:endParaRPr sz="800">
+              <a:solidFill>
+                <a:schemeClr val="dk2"/>
+              </a:solidFill>
+            </a:endParaRPr>
+          </a:p>
+        </p:txBody>
+      </p:sp>
     </p:spTree>
   </p:cSld>
   <p:clrMapOvr>
     <a:masterClrMapping/>
   </p:clrMapOvr>
-  <p:timing>
-    <p:tnLst>
-      <p:par>
-        <p:cTn id="1" dur="indefinite" restart="never" nodeType="tmRoot">
-          <p:childTnLst>
-            <p:seq concurrent="1" nextAc="seek">
-              <p:cTn id="2" dur="indefinite" nodeType="mainSeq">
-                <p:childTnLst>
-                  <p:par>
-                    <p:cTn id="3" fill="hold">
-                      <p:stCondLst>
-                        <p:cond delay="indefinite"/>
-                      </p:stCondLst>
-                      <p:childTnLst>
-                        <p:par>
-                          <p:cTn id="4" fill="hold">
-                            <p:stCondLst>
-                              <p:cond delay="0"/>
-                            </p:stCondLst>
-                            <p:childTnLst>
-                              <p:par>
-                                <p:cTn id="5" presetID="1" presetClass="exit" presetSubtype="0" fill="hold" nodeType="clickEffect">
-                                  <p:stCondLst>
-                                    <p:cond delay="0"/>
-                                  </p:stCondLst>
-                                  <p:childTnLst>
-                                    <p:set>
-                                      <p:cBhvr>
-                                        <p:cTn id="6" dur="1" fill="hold">
-                                          <p:stCondLst>
-                                            <p:cond delay="0"/>
-                                          </p:stCondLst>
-                                        </p:cTn>
-                                        <p:tgtEl>
-                                          <p:spTgt spid="69"/>
-                                        </p:tgtEl>
-                                        <p:attrNameLst>
-                                          <p:attrName>style.visibility</p:attrName>
-                                        </p:attrNameLst>
-                                      </p:cBhvr>
-                                      <p:to>
-                                        <p:strVal val="hidden"/>
-                                      </p:to>
-                                    </p:set>
-                                  </p:childTnLst>
-                                </p:cTn>
-                              </p:par>
-                            </p:childTnLst>
-                          </p:cTn>
-                        </p:par>
-                      </p:childTnLst>
-                    </p:cTn>
-                  </p:par>
-                </p:childTnLst>
-              </p:cTn>
-              <p:prevCondLst>
-                <p:cond evt="onPrev" delay="0">
-                  <p:tgtEl>
-                    <p:sldTgt/>
-                  </p:tgtEl>
-                </p:cond>
-              </p:prevCondLst>
-              <p:nextCondLst>
-                <p:cond evt="onNext" delay="0">
-                  <p:tgtEl>
-                    <p:sldTgt/>
-                  </p:tgtEl>
-                </p:cond>
-              </p:nextCondLst>
-            </p:seq>
-          </p:childTnLst>
-        </p:cTn>
-      </p:par>
-    </p:tnLst>
-  </p:timing>
 </p:sld>
 </file>
 
-<file path=ppt/slides/slide20.xml><?xml version="1.0" encoding="utf-8"?>
+<file path=ppt/slides/slide21.xml><?xml version="1.0" encoding="utf-8"?>
 <p:sld xmlns:a="http://schemas.openxmlformats.org/drawingml/2006/main" xmlns:r="http://schemas.openxmlformats.org/officeDocument/2006/relationships" xmlns:p="http://schemas.openxmlformats.org/presentationml/2006/main">
   <p:cSld>
     <p:spTree>
@@ -12772,22 +13162,14 @@
           </a:bodyPr>
           <a:lstStyle/>
           <a:p>
-            <a:pPr marL="0" lvl="0" indent="0" algn="ctr" rtl="0">
-              <a:spcBef>
-                <a:spcPts val="0"/>
-              </a:spcBef>
-              <a:spcAft>
-                <a:spcPts val="0"/>
-              </a:spcAft>
-              <a:buNone/>
-            </a:pPr>
+            <a:pPr lvl="0" algn="ctr"/>
             <a:r>
               <a:rPr lang="en-GB" sz="800" dirty="0">
                 <a:solidFill>
                   <a:schemeClr val="dk2"/>
                 </a:solidFill>
               </a:rPr>
-              <a:t>Page 20</a:t>
+              <a:t>Page 20 : presenter Emaan</a:t>
             </a:r>
             <a:endParaRPr sz="800" dirty="0">
               <a:solidFill>
@@ -12909,12 +13291,47 @@
           </a:p>
         </p:txBody>
       </p:sp>
+      <p:sp>
+        <p:nvSpPr>
+          <p:cNvPr id="2" name="Rectangle 1">
+            <a:extLst>
+              <a:ext uri="{FF2B5EF4-FFF2-40B4-BE49-F238E27FC236}">
+                <a16:creationId xmlns:a16="http://schemas.microsoft.com/office/drawing/2014/main" id="{567A0067-09E1-43BA-9D34-2D2D9BA676E7}"/>
+              </a:ext>
+            </a:extLst>
+          </p:cNvPr>
+          <p:cNvSpPr/>
+          <p:nvPr/>
+        </p:nvSpPr>
+        <p:spPr>
+          <a:xfrm>
+            <a:off x="5509752" y="4414691"/>
+            <a:ext cx="1725355" cy="323165"/>
+          </a:xfrm>
+          <a:prstGeom prst="rect">
+            <a:avLst/>
+          </a:prstGeom>
+        </p:spPr>
+        <p:txBody>
+          <a:bodyPr wrap="square">
+            <a:spAutoFit/>
+          </a:bodyPr>
+          <a:lstStyle/>
+          <a:p>
+            <a:r>
+              <a:rPr lang="en-US" sz="1500" dirty="0"/>
+              <a:t>Fig: PCB Layout</a:t>
+            </a:r>
+            <a:endParaRPr lang="en-US" dirty="0"/>
+          </a:p>
+        </p:txBody>
+      </p:sp>
       <p:pic>
         <p:nvPicPr>
-          <p:cNvPr id="1026" name="Picture 2" descr="https://lh7-rt.googleusercontent.com/slidesz/AGV_vUf_K22Ka0hcfuUDwdES_n5GY5aj7ju9OFzCBPf17Xed2GB5UFDUnviy2Hc-nhM_7sLFejdh9yGkLn6mN-A_bOvSz2CnA3x8kMAKPxpigVh3LO4p5fx0vFOTPmlGVwivkXilAS3bhQ=s2048?key=lRNno0ZX1l3jrIPIVq1ymw">
+          <p:cNvPr id="3" name="Picture 2" descr="https://lh7-rt.googleusercontent.com/slidesz/AGV_vUeaHeUzd8Dww-55W8w3_qLBlV-t3yLNu9dQ3WJCZzN8isGo-7Uy6qBnBCUx205W_W7fDh60vGZ7RXSBq3OAUoySlzgf3MtvFkMRtqg2PpuZ_vQF6M-yV52a1yXZjkek1dJurcozaA=s2048?key=lRNno0ZX1l3jrIPIVq1ymw">
             <a:extLst>
               <a:ext uri="{FF2B5EF4-FFF2-40B4-BE49-F238E27FC236}">
-                <a16:creationId xmlns:a16="http://schemas.microsoft.com/office/drawing/2014/main" id="{8C71DDF5-9C1A-4AC4-8D81-9D2C2FE50F26}"/>
+                <a16:creationId xmlns:a16="http://schemas.microsoft.com/office/drawing/2014/main" id="{758B6049-33C7-4C59-A0FE-595F59633DEA}"/>
               </a:ext>
             </a:extLst>
           </p:cNvPr>
@@ -12938,8 +13355,8 @@
         </p:blipFill>
         <p:spPr bwMode="auto">
           <a:xfrm>
-            <a:off x="5993113" y="1103150"/>
-            <a:ext cx="3052731" cy="3301351"/>
+            <a:off x="5557849" y="530450"/>
+            <a:ext cx="3512732" cy="3798816"/>
           </a:xfrm>
           <a:prstGeom prst="rect">
             <a:avLst/>
@@ -12956,41 +13373,6 @@
           </a:extLst>
         </p:spPr>
       </p:pic>
-      <p:sp>
-        <p:nvSpPr>
-          <p:cNvPr id="2" name="Rectangle 1">
-            <a:extLst>
-              <a:ext uri="{FF2B5EF4-FFF2-40B4-BE49-F238E27FC236}">
-                <a16:creationId xmlns:a16="http://schemas.microsoft.com/office/drawing/2014/main" id="{567A0067-09E1-43BA-9D34-2D2D9BA676E7}"/>
-              </a:ext>
-            </a:extLst>
-          </p:cNvPr>
-          <p:cNvSpPr/>
-          <p:nvPr/>
-        </p:nvSpPr>
-        <p:spPr>
-          <a:xfrm>
-            <a:off x="5896870" y="4415735"/>
-            <a:ext cx="1725355" cy="323165"/>
-          </a:xfrm>
-          <a:prstGeom prst="rect">
-            <a:avLst/>
-          </a:prstGeom>
-        </p:spPr>
-        <p:txBody>
-          <a:bodyPr wrap="square">
-            <a:spAutoFit/>
-          </a:bodyPr>
-          <a:lstStyle/>
-          <a:p>
-            <a:r>
-              <a:rPr lang="en-US" sz="1500" dirty="0"/>
-              <a:t>Fig: PCB Layout</a:t>
-            </a:r>
-            <a:endParaRPr lang="en-US" dirty="0"/>
-          </a:p>
-        </p:txBody>
-      </p:sp>
     </p:spTree>
   </p:cSld>
   <p:clrMapOvr>
@@ -12999,7 +13381,7 @@
 </p:sld>
 </file>
 
-<file path=ppt/slides/slide21.xml><?xml version="1.0" encoding="utf-8"?>
+<file path=ppt/slides/slide22.xml><?xml version="1.0" encoding="utf-8"?>
 <p:sld xmlns:a="http://schemas.openxmlformats.org/drawingml/2006/main" xmlns:r="http://schemas.openxmlformats.org/officeDocument/2006/relationships" xmlns:p="http://schemas.openxmlformats.org/presentationml/2006/main">
   <p:cSld>
     <p:spTree>
@@ -13065,6 +13447,10 @@
           </p:nvPr>
         </p:nvSpPr>
         <p:spPr>
+          <a:xfrm>
+            <a:off x="311700" y="1152475"/>
+            <a:ext cx="4487231" cy="3416400"/>
+          </a:xfrm>
           <a:prstGeom prst="rect">
             <a:avLst/>
           </a:prstGeom>
@@ -13396,8 +13782,8 @@
         </p:blipFill>
         <p:spPr>
           <a:xfrm>
-            <a:off x="6995178" y="2695575"/>
-            <a:ext cx="2148822" cy="2447925"/>
+            <a:off x="4874781" y="2548128"/>
+            <a:ext cx="1728669" cy="1913466"/>
           </a:xfrm>
           <a:prstGeom prst="rect">
             <a:avLst/>
@@ -13424,7 +13810,7 @@
         </p:blipFill>
         <p:spPr>
           <a:xfrm>
-            <a:off x="4613925" y="3962400"/>
+            <a:off x="2417681" y="3723487"/>
             <a:ext cx="2381250" cy="1181100"/>
           </a:xfrm>
           <a:prstGeom prst="rect">
@@ -13452,7 +13838,7 @@
         </p:blipFill>
         <p:spPr>
           <a:xfrm>
-            <a:off x="6915150" y="46500"/>
+            <a:off x="6743434" y="2499525"/>
             <a:ext cx="2228850" cy="2447925"/>
           </a:xfrm>
           <a:prstGeom prst="rect">
@@ -13480,8 +13866,8 @@
         </p:blipFill>
         <p:spPr>
           <a:xfrm>
-            <a:off x="29525" y="3573225"/>
-            <a:ext cx="2767300" cy="1570275"/>
+            <a:off x="5347760" y="324777"/>
+            <a:ext cx="3624524" cy="2116071"/>
           </a:xfrm>
           <a:prstGeom prst="rect">
             <a:avLst/>
@@ -13523,22 +13909,14 @@
           </a:bodyPr>
           <a:lstStyle/>
           <a:p>
-            <a:pPr marL="0" lvl="0" indent="0" algn="ctr" rtl="0">
-              <a:spcBef>
-                <a:spcPts val="0"/>
-              </a:spcBef>
-              <a:spcAft>
-                <a:spcPts val="0"/>
-              </a:spcAft>
-              <a:buNone/>
-            </a:pPr>
+            <a:pPr lvl="0" algn="ctr"/>
             <a:r>
               <a:rPr lang="en-GB" sz="800" dirty="0">
                 <a:solidFill>
                   <a:schemeClr val="dk2"/>
                 </a:solidFill>
               </a:rPr>
-              <a:t>Page 21</a:t>
+              <a:t>Page 21 : presenter Emaan</a:t>
             </a:r>
             <a:endParaRPr sz="800" dirty="0">
               <a:solidFill>
@@ -13689,7 +14067,7 @@
         </p:blipFill>
         <p:spPr bwMode="auto">
           <a:xfrm>
-            <a:off x="4705267" y="3114968"/>
+            <a:off x="212271" y="3723487"/>
             <a:ext cx="2148823" cy="693169"/>
           </a:xfrm>
           <a:prstGeom prst="rect">
@@ -13715,7 +14093,7 @@
 </p:sld>
 </file>
 
-<file path=ppt/slides/slide22.xml><?xml version="1.0" encoding="utf-8"?>
+<file path=ppt/slides/slide23.xml><?xml version="1.0" encoding="utf-8"?>
 <p:sld xmlns:a="http://schemas.openxmlformats.org/drawingml/2006/main" xmlns:r="http://schemas.openxmlformats.org/officeDocument/2006/relationships" xmlns:p="http://schemas.openxmlformats.org/presentationml/2006/main">
   <p:cSld>
     <p:spTree>
@@ -13969,6 +14347,272 @@
   <p:cSld>
     <p:spTree>
       <p:nvGrpSpPr>
+        <p:cNvPr id="1" name="Shape 63"/>
+        <p:cNvGrpSpPr/>
+        <p:nvPr/>
+      </p:nvGrpSpPr>
+      <p:grpSpPr>
+        <a:xfrm>
+          <a:off x="0" y="0"/>
+          <a:ext cx="0" cy="0"/>
+          <a:chOff x="0" y="0"/>
+          <a:chExt cx="0" cy="0"/>
+        </a:xfrm>
+      </p:grpSpPr>
+      <p:sp>
+        <p:nvSpPr>
+          <p:cNvPr id="64" name="Google Shape;64;p14"/>
+          <p:cNvSpPr txBox="1">
+            <a:spLocks noGrp="1"/>
+          </p:cNvSpPr>
+          <p:nvPr>
+            <p:ph type="title"/>
+          </p:nvPr>
+        </p:nvSpPr>
+        <p:spPr>
+          <a:prstGeom prst="rect">
+            <a:avLst/>
+          </a:prstGeom>
+        </p:spPr>
+        <p:txBody>
+          <a:bodyPr spcFirstLastPara="1" wrap="square" lIns="91425" tIns="91425" rIns="91425" bIns="91425" anchor="t" anchorCtr="0">
+            <a:normAutofit fontScale="90000"/>
+          </a:bodyPr>
+          <a:lstStyle/>
+          <a:p>
+            <a:pPr marL="0" lvl="0" indent="0" algn="l" rtl="0">
+              <a:spcBef>
+                <a:spcPts val="0"/>
+              </a:spcBef>
+              <a:spcAft>
+                <a:spcPts val="0"/>
+              </a:spcAft>
+              <a:buNone/>
+            </a:pPr>
+            <a:r>
+              <a:rPr lang="en-GB"/>
+              <a:t>Concepts with diagrams_block diagram</a:t>
+            </a:r>
+            <a:endParaRPr/>
+          </a:p>
+        </p:txBody>
+      </p:sp>
+      <p:sp>
+        <p:nvSpPr>
+          <p:cNvPr id="65" name="Google Shape;65;p14"/>
+          <p:cNvSpPr txBox="1"/>
+          <p:nvPr/>
+        </p:nvSpPr>
+        <p:spPr>
+          <a:xfrm>
+            <a:off x="0" y="0"/>
+            <a:ext cx="1662900" cy="266100"/>
+          </a:xfrm>
+          <a:prstGeom prst="rect">
+            <a:avLst/>
+          </a:prstGeom>
+          <a:noFill/>
+          <a:ln>
+            <a:noFill/>
+          </a:ln>
+        </p:spPr>
+        <p:txBody>
+          <a:bodyPr spcFirstLastPara="1" wrap="square" lIns="91425" tIns="91425" rIns="91425" bIns="91425" anchor="t" anchorCtr="0">
+            <a:noAutofit/>
+          </a:bodyPr>
+          <a:lstStyle/>
+          <a:p>
+            <a:pPr marL="0" lvl="0" indent="0" algn="l" rtl="0">
+              <a:spcBef>
+                <a:spcPts val="0"/>
+              </a:spcBef>
+              <a:spcAft>
+                <a:spcPts val="0"/>
+              </a:spcAft>
+              <a:buNone/>
+            </a:pPr>
+            <a:r>
+              <a:rPr lang="en-GB" sz="800">
+                <a:solidFill>
+                  <a:schemeClr val="dk2"/>
+                </a:solidFill>
+              </a:rPr>
+              <a:t>Hardware Engineering Lab</a:t>
+            </a:r>
+            <a:endParaRPr sz="800">
+              <a:solidFill>
+                <a:schemeClr val="dk2"/>
+              </a:solidFill>
+            </a:endParaRPr>
+          </a:p>
+        </p:txBody>
+      </p:sp>
+      <p:sp>
+        <p:nvSpPr>
+          <p:cNvPr id="66" name="Google Shape;66;p14"/>
+          <p:cNvSpPr txBox="1"/>
+          <p:nvPr/>
+        </p:nvSpPr>
+        <p:spPr>
+          <a:xfrm>
+            <a:off x="7481100" y="0"/>
+            <a:ext cx="1662900" cy="266100"/>
+          </a:xfrm>
+          <a:prstGeom prst="rect">
+            <a:avLst/>
+          </a:prstGeom>
+          <a:noFill/>
+          <a:ln>
+            <a:noFill/>
+          </a:ln>
+        </p:spPr>
+        <p:txBody>
+          <a:bodyPr spcFirstLastPara="1" wrap="square" lIns="91425" tIns="91425" rIns="91425" bIns="91425" anchor="t" anchorCtr="0">
+            <a:noAutofit/>
+          </a:bodyPr>
+          <a:lstStyle/>
+          <a:p>
+            <a:pPr marL="0" lvl="0" indent="0" algn="r" rtl="0">
+              <a:spcBef>
+                <a:spcPts val="0"/>
+              </a:spcBef>
+              <a:spcAft>
+                <a:spcPts val="0"/>
+              </a:spcAft>
+              <a:buNone/>
+            </a:pPr>
+            <a:r>
+              <a:rPr lang="en-GB" sz="800">
+                <a:solidFill>
+                  <a:schemeClr val="dk2"/>
+                </a:solidFill>
+              </a:rPr>
+              <a:t>Summer Term 2025</a:t>
+            </a:r>
+            <a:endParaRPr sz="800">
+              <a:solidFill>
+                <a:schemeClr val="dk2"/>
+              </a:solidFill>
+            </a:endParaRPr>
+          </a:p>
+        </p:txBody>
+      </p:sp>
+      <p:sp>
+        <p:nvSpPr>
+          <p:cNvPr id="67" name="Google Shape;67;p14"/>
+          <p:cNvSpPr txBox="1"/>
+          <p:nvPr/>
+        </p:nvSpPr>
+        <p:spPr>
+          <a:xfrm>
+            <a:off x="3783275" y="4877400"/>
+            <a:ext cx="1662900" cy="266100"/>
+          </a:xfrm>
+          <a:prstGeom prst="rect">
+            <a:avLst/>
+          </a:prstGeom>
+          <a:noFill/>
+          <a:ln>
+            <a:noFill/>
+          </a:ln>
+        </p:spPr>
+        <p:txBody>
+          <a:bodyPr spcFirstLastPara="1" wrap="square" lIns="91425" tIns="91425" rIns="91425" bIns="91425" anchor="t" anchorCtr="0">
+            <a:noAutofit/>
+          </a:bodyPr>
+          <a:lstStyle/>
+          <a:p>
+            <a:pPr lvl="0" algn="ctr"/>
+            <a:r>
+              <a:rPr lang="en-GB" sz="800" dirty="0">
+                <a:solidFill>
+                  <a:schemeClr val="dk2"/>
+                </a:solidFill>
+              </a:rPr>
+              <a:t>Page 2 : presenter Choi</a:t>
+            </a:r>
+            <a:endParaRPr sz="800" dirty="0">
+              <a:solidFill>
+                <a:schemeClr val="dk2"/>
+              </a:solidFill>
+            </a:endParaRPr>
+          </a:p>
+        </p:txBody>
+      </p:sp>
+      <p:pic>
+        <p:nvPicPr>
+          <p:cNvPr id="68" name="Google Shape;68;p14"/>
+          <p:cNvPicPr preferRelativeResize="0"/>
+          <p:nvPr/>
+        </p:nvPicPr>
+        <p:blipFill>
+          <a:blip r:embed="rId3">
+            <a:alphaModFix/>
+          </a:blip>
+          <a:stretch>
+            <a:fillRect/>
+          </a:stretch>
+        </p:blipFill>
+        <p:spPr>
+          <a:xfrm>
+            <a:off x="145000" y="1051900"/>
+            <a:ext cx="5846127" cy="3685151"/>
+          </a:xfrm>
+          <a:prstGeom prst="rect">
+            <a:avLst/>
+          </a:prstGeom>
+          <a:noFill/>
+          <a:ln>
+            <a:noFill/>
+          </a:ln>
+        </p:spPr>
+      </p:pic>
+      <p:pic>
+        <p:nvPicPr>
+          <p:cNvPr id="69" name="Google Shape;69;p14"/>
+          <p:cNvPicPr preferRelativeResize="0"/>
+          <p:nvPr/>
+        </p:nvPicPr>
+        <p:blipFill>
+          <a:blip r:embed="rId4">
+            <a:alphaModFix/>
+          </a:blip>
+          <a:stretch>
+            <a:fillRect/>
+          </a:stretch>
+        </p:blipFill>
+        <p:spPr>
+          <a:xfrm>
+            <a:off x="5929290" y="1428775"/>
+            <a:ext cx="3103620" cy="2931399"/>
+          </a:xfrm>
+          <a:prstGeom prst="rect">
+            <a:avLst/>
+          </a:prstGeom>
+          <a:noFill/>
+          <a:ln>
+            <a:noFill/>
+          </a:ln>
+        </p:spPr>
+      </p:pic>
+    </p:spTree>
+    <p:extLst>
+      <p:ext uri="{BB962C8B-B14F-4D97-AF65-F5344CB8AC3E}">
+        <p14:creationId xmlns:p14="http://schemas.microsoft.com/office/powerpoint/2010/main" val="75087458"/>
+      </p:ext>
+    </p:extLst>
+  </p:cSld>
+  <p:clrMapOvr>
+    <a:masterClrMapping/>
+  </p:clrMapOvr>
+</p:sld>
+</file>
+
+<file path=ppt/slides/slide4.xml><?xml version="1.0" encoding="utf-8"?>
+<p:sld xmlns:a="http://schemas.openxmlformats.org/drawingml/2006/main" xmlns:r="http://schemas.openxmlformats.org/officeDocument/2006/relationships" xmlns:p="http://schemas.openxmlformats.org/presentationml/2006/main">
+  <p:cSld>
+    <p:spTree>
+      <p:nvGrpSpPr>
         <p:cNvPr id="1" name="Shape 73"/>
         <p:cNvGrpSpPr/>
         <p:nvPr/>
@@ -14172,24 +14816,16 @@
           </a:bodyPr>
           <a:lstStyle/>
           <a:p>
-            <a:pPr marL="0" lvl="0" indent="0" algn="ctr" rtl="0">
-              <a:spcBef>
-                <a:spcPts val="0"/>
-              </a:spcBef>
-              <a:spcAft>
-                <a:spcPts val="0"/>
-              </a:spcAft>
-              <a:buNone/>
-            </a:pPr>
-            <a:r>
-              <a:rPr lang="en-GB" sz="800">
+            <a:pPr lvl="0" algn="ctr"/>
+            <a:r>
+              <a:rPr lang="en-GB" sz="800" dirty="0">
                 <a:solidFill>
                   <a:schemeClr val="dk2"/>
                 </a:solidFill>
               </a:rPr>
-              <a:t>Page 3</a:t>
-            </a:r>
-            <a:endParaRPr sz="800">
+              <a:t>Page 3 : presenter Choi</a:t>
+            </a:r>
+            <a:endParaRPr sz="800" dirty="0">
               <a:solidFill>
                 <a:schemeClr val="dk2"/>
               </a:solidFill>
@@ -14205,7 +14841,7 @@
 </p:sld>
 </file>
 
-<file path=ppt/slides/slide4.xml><?xml version="1.0" encoding="utf-8"?>
+<file path=ppt/slides/slide5.xml><?xml version="1.0" encoding="utf-8"?>
 <p:sld xmlns:a="http://schemas.openxmlformats.org/drawingml/2006/main" xmlns:r="http://schemas.openxmlformats.org/officeDocument/2006/relationships" xmlns:p="http://schemas.openxmlformats.org/presentationml/2006/main">
   <p:cSld>
     <p:spTree>
@@ -14347,24 +14983,16 @@
           </a:bodyPr>
           <a:lstStyle/>
           <a:p>
-            <a:pPr marL="0" lvl="0" indent="0" algn="ctr" rtl="0">
-              <a:spcBef>
-                <a:spcPts val="0"/>
-              </a:spcBef>
-              <a:spcAft>
-                <a:spcPts val="0"/>
-              </a:spcAft>
-              <a:buNone/>
-            </a:pPr>
-            <a:r>
-              <a:rPr lang="en-GB" sz="800">
+            <a:pPr lvl="0" algn="ctr"/>
+            <a:r>
+              <a:rPr lang="en-GB" sz="800" dirty="0">
                 <a:solidFill>
                   <a:schemeClr val="dk2"/>
                 </a:solidFill>
               </a:rPr>
-              <a:t>Page 4</a:t>
-            </a:r>
-            <a:endParaRPr sz="800">
+              <a:t>Page 4 : presenter Leano</a:t>
+            </a:r>
+            <a:endParaRPr sz="800" dirty="0">
               <a:solidFill>
                 <a:schemeClr val="dk2"/>
               </a:solidFill>
@@ -14513,7 +15141,7 @@
 </p:sld>
 </file>
 
-<file path=ppt/slides/slide5.xml><?xml version="1.0" encoding="utf-8"?>
+<file path=ppt/slides/slide6.xml><?xml version="1.0" encoding="utf-8"?>
 <p:sld xmlns:a="http://schemas.openxmlformats.org/drawingml/2006/main" xmlns:r="http://schemas.openxmlformats.org/officeDocument/2006/relationships" xmlns:p="http://schemas.openxmlformats.org/presentationml/2006/main">
   <p:cSld>
     <p:spTree>
@@ -14655,24 +15283,16 @@
           </a:bodyPr>
           <a:lstStyle/>
           <a:p>
-            <a:pPr marL="0" lvl="0" indent="0" algn="ctr" rtl="0">
-              <a:spcBef>
-                <a:spcPts val="0"/>
-              </a:spcBef>
-              <a:spcAft>
-                <a:spcPts val="0"/>
-              </a:spcAft>
-              <a:buNone/>
-            </a:pPr>
-            <a:r>
-              <a:rPr lang="en-GB" sz="800">
+            <a:pPr lvl="0" algn="ctr"/>
+            <a:r>
+              <a:rPr lang="en-GB" sz="800" dirty="0">
                 <a:solidFill>
                   <a:schemeClr val="dk2"/>
                 </a:solidFill>
               </a:rPr>
-              <a:t>Page 5</a:t>
-            </a:r>
-            <a:endParaRPr sz="800">
+              <a:t>Page 5 : presenter Leano</a:t>
+            </a:r>
+            <a:endParaRPr sz="800" dirty="0">
               <a:solidFill>
                 <a:schemeClr val="dk2"/>
               </a:solidFill>
@@ -14819,7 +15439,7 @@
         </p:nvSpPr>
         <p:spPr>
           <a:xfrm>
-            <a:off x="373787" y="2292077"/>
+            <a:off x="373787" y="2198635"/>
             <a:ext cx="2776572" cy="2862322"/>
           </a:xfrm>
           <a:prstGeom prst="rect">
@@ -14870,7 +15490,7 @@
 </p:sld>
 </file>
 
-<file path=ppt/slides/slide6.xml><?xml version="1.0" encoding="utf-8"?>
+<file path=ppt/slides/slide7.xml><?xml version="1.0" encoding="utf-8"?>
 <p:sld xmlns:a="http://schemas.openxmlformats.org/drawingml/2006/main" xmlns:r="http://schemas.openxmlformats.org/officeDocument/2006/relationships" xmlns:p="http://schemas.openxmlformats.org/presentationml/2006/main">
   <p:cSld>
     <p:spTree>
@@ -15012,24 +15632,16 @@
           </a:bodyPr>
           <a:lstStyle/>
           <a:p>
-            <a:pPr marL="0" lvl="0" indent="0" algn="ctr" rtl="0">
-              <a:spcBef>
-                <a:spcPts val="0"/>
-              </a:spcBef>
-              <a:spcAft>
-                <a:spcPts val="0"/>
-              </a:spcAft>
-              <a:buNone/>
-            </a:pPr>
-            <a:r>
-              <a:rPr lang="en-GB" sz="800">
+            <a:pPr lvl="0" algn="ctr"/>
+            <a:r>
+              <a:rPr lang="en-GB" sz="800" dirty="0">
                 <a:solidFill>
                   <a:schemeClr val="dk2"/>
                 </a:solidFill>
               </a:rPr>
-              <a:t>Page 6</a:t>
-            </a:r>
-            <a:endParaRPr sz="800">
+              <a:t>Page 6 : presenter Leano</a:t>
+            </a:r>
+            <a:endParaRPr sz="800" dirty="0">
               <a:solidFill>
                 <a:schemeClr val="dk2"/>
               </a:solidFill>
@@ -15320,7 +15932,7 @@
 </p:sld>
 </file>
 
-<file path=ppt/slides/slide7.xml><?xml version="1.0" encoding="utf-8"?>
+<file path=ppt/slides/slide8.xml><?xml version="1.0" encoding="utf-8"?>
 <p:sld xmlns:a="http://schemas.openxmlformats.org/drawingml/2006/main" xmlns:r="http://schemas.openxmlformats.org/officeDocument/2006/relationships" xmlns:p="http://schemas.openxmlformats.org/presentationml/2006/main">
   <p:cSld>
     <p:spTree>
@@ -15462,24 +16074,16 @@
           </a:bodyPr>
           <a:lstStyle/>
           <a:p>
-            <a:pPr marL="0" lvl="0" indent="0" algn="ctr" rtl="0">
-              <a:spcBef>
-                <a:spcPts val="0"/>
-              </a:spcBef>
-              <a:spcAft>
-                <a:spcPts val="0"/>
-              </a:spcAft>
-              <a:buNone/>
-            </a:pPr>
-            <a:r>
-              <a:rPr lang="en-GB" sz="800">
+            <a:pPr lvl="0" algn="ctr"/>
+            <a:r>
+              <a:rPr lang="en-GB" sz="800" dirty="0">
                 <a:solidFill>
                   <a:schemeClr val="dk2"/>
                 </a:solidFill>
               </a:rPr>
-              <a:t>Page 7</a:t>
-            </a:r>
-            <a:endParaRPr sz="800">
+              <a:t>Page 7 : presenter Leano</a:t>
+            </a:r>
+            <a:endParaRPr sz="800" dirty="0">
               <a:solidFill>
                 <a:schemeClr val="dk2"/>
               </a:solidFill>
@@ -15674,7 +16278,7 @@
 </p:sld>
 </file>
 
-<file path=ppt/slides/slide8.xml><?xml version="1.0" encoding="utf-8"?>
+<file path=ppt/slides/slide9.xml><?xml version="1.0" encoding="utf-8"?>
 <p:sld xmlns:a="http://schemas.openxmlformats.org/drawingml/2006/main" xmlns:r="http://schemas.openxmlformats.org/officeDocument/2006/relationships" xmlns:p="http://schemas.openxmlformats.org/presentationml/2006/main">
   <p:cSld>
     <p:spTree>
@@ -15816,24 +16420,16 @@
           </a:bodyPr>
           <a:lstStyle/>
           <a:p>
-            <a:pPr marL="0" lvl="0" indent="0" algn="ctr" rtl="0">
-              <a:spcBef>
-                <a:spcPts val="0"/>
-              </a:spcBef>
-              <a:spcAft>
-                <a:spcPts val="0"/>
-              </a:spcAft>
-              <a:buNone/>
-            </a:pPr>
-            <a:r>
-              <a:rPr lang="en-GB" sz="800">
+            <a:pPr lvl="0" algn="ctr"/>
+            <a:r>
+              <a:rPr lang="en-GB" sz="800" dirty="0">
                 <a:solidFill>
                   <a:schemeClr val="dk2"/>
                 </a:solidFill>
               </a:rPr>
-              <a:t>Page 8</a:t>
-            </a:r>
-            <a:endParaRPr sz="800">
+              <a:t>Page 8 : presenter Leano</a:t>
+            </a:r>
+            <a:endParaRPr sz="800" dirty="0">
               <a:solidFill>
                 <a:schemeClr val="dk2"/>
               </a:solidFill>
@@ -15937,315 +16533,6 @@
           <a:xfrm>
             <a:off x="5360900" y="980675"/>
             <a:ext cx="3206426" cy="3953126"/>
-          </a:xfrm>
-          <a:prstGeom prst="rect">
-            <a:avLst/>
-          </a:prstGeom>
-          <a:noFill/>
-          <a:ln>
-            <a:noFill/>
-          </a:ln>
-        </p:spPr>
-      </p:pic>
-    </p:spTree>
-  </p:cSld>
-  <p:clrMapOvr>
-    <a:masterClrMapping/>
-  </p:clrMapOvr>
-</p:sld>
-</file>
-
-<file path=ppt/slides/slide9.xml><?xml version="1.0" encoding="utf-8"?>
-<p:sld xmlns:a="http://schemas.openxmlformats.org/drawingml/2006/main" xmlns:r="http://schemas.openxmlformats.org/officeDocument/2006/relationships" xmlns:p="http://schemas.openxmlformats.org/presentationml/2006/main">
-  <p:cSld>
-    <p:spTree>
-      <p:nvGrpSpPr>
-        <p:cNvPr id="1" name="Shape 134"/>
-        <p:cNvGrpSpPr/>
-        <p:nvPr/>
-      </p:nvGrpSpPr>
-      <p:grpSpPr>
-        <a:xfrm>
-          <a:off x="0" y="0"/>
-          <a:ext cx="0" cy="0"/>
-          <a:chOff x="0" y="0"/>
-          <a:chExt cx="0" cy="0"/>
-        </a:xfrm>
-      </p:grpSpPr>
-      <p:sp>
-        <p:nvSpPr>
-          <p:cNvPr id="135" name="Google Shape;135;p21"/>
-          <p:cNvSpPr txBox="1"/>
-          <p:nvPr/>
-        </p:nvSpPr>
-        <p:spPr>
-          <a:xfrm>
-            <a:off x="0" y="0"/>
-            <a:ext cx="1662900" cy="266100"/>
-          </a:xfrm>
-          <a:prstGeom prst="rect">
-            <a:avLst/>
-          </a:prstGeom>
-          <a:noFill/>
-          <a:ln>
-            <a:noFill/>
-          </a:ln>
-        </p:spPr>
-        <p:txBody>
-          <a:bodyPr spcFirstLastPara="1" wrap="square" lIns="91425" tIns="91425" rIns="91425" bIns="91425" anchor="t" anchorCtr="0">
-            <a:noAutofit/>
-          </a:bodyPr>
-          <a:lstStyle/>
-          <a:p>
-            <a:pPr marL="0" lvl="0" indent="0" algn="l" rtl="0">
-              <a:spcBef>
-                <a:spcPts val="0"/>
-              </a:spcBef>
-              <a:spcAft>
-                <a:spcPts val="0"/>
-              </a:spcAft>
-              <a:buNone/>
-            </a:pPr>
-            <a:r>
-              <a:rPr lang="en-GB" sz="800">
-                <a:solidFill>
-                  <a:schemeClr val="dk2"/>
-                </a:solidFill>
-              </a:rPr>
-              <a:t>Hardware Engineering Lab</a:t>
-            </a:r>
-            <a:endParaRPr sz="800">
-              <a:solidFill>
-                <a:schemeClr val="dk2"/>
-              </a:solidFill>
-            </a:endParaRPr>
-          </a:p>
-        </p:txBody>
-      </p:sp>
-      <p:sp>
-        <p:nvSpPr>
-          <p:cNvPr id="136" name="Google Shape;136;p21"/>
-          <p:cNvSpPr txBox="1"/>
-          <p:nvPr/>
-        </p:nvSpPr>
-        <p:spPr>
-          <a:xfrm>
-            <a:off x="7481100" y="0"/>
-            <a:ext cx="1662900" cy="266100"/>
-          </a:xfrm>
-          <a:prstGeom prst="rect">
-            <a:avLst/>
-          </a:prstGeom>
-          <a:noFill/>
-          <a:ln>
-            <a:noFill/>
-          </a:ln>
-        </p:spPr>
-        <p:txBody>
-          <a:bodyPr spcFirstLastPara="1" wrap="square" lIns="91425" tIns="91425" rIns="91425" bIns="91425" anchor="t" anchorCtr="0">
-            <a:noAutofit/>
-          </a:bodyPr>
-          <a:lstStyle/>
-          <a:p>
-            <a:pPr marL="0" lvl="0" indent="0" algn="r" rtl="0">
-              <a:spcBef>
-                <a:spcPts val="0"/>
-              </a:spcBef>
-              <a:spcAft>
-                <a:spcPts val="0"/>
-              </a:spcAft>
-              <a:buNone/>
-            </a:pPr>
-            <a:r>
-              <a:rPr lang="en-GB" sz="800">
-                <a:solidFill>
-                  <a:schemeClr val="dk2"/>
-                </a:solidFill>
-              </a:rPr>
-              <a:t>Summer Term 2025</a:t>
-            </a:r>
-            <a:endParaRPr sz="800">
-              <a:solidFill>
-                <a:schemeClr val="dk2"/>
-              </a:solidFill>
-            </a:endParaRPr>
-          </a:p>
-        </p:txBody>
-      </p:sp>
-      <p:sp>
-        <p:nvSpPr>
-          <p:cNvPr id="137" name="Google Shape;137;p21"/>
-          <p:cNvSpPr txBox="1"/>
-          <p:nvPr/>
-        </p:nvSpPr>
-        <p:spPr>
-          <a:xfrm>
-            <a:off x="3783275" y="4877400"/>
-            <a:ext cx="1662900" cy="266100"/>
-          </a:xfrm>
-          <a:prstGeom prst="rect">
-            <a:avLst/>
-          </a:prstGeom>
-          <a:noFill/>
-          <a:ln>
-            <a:noFill/>
-          </a:ln>
-        </p:spPr>
-        <p:txBody>
-          <a:bodyPr spcFirstLastPara="1" wrap="square" lIns="91425" tIns="91425" rIns="91425" bIns="91425" anchor="t" anchorCtr="0">
-            <a:noAutofit/>
-          </a:bodyPr>
-          <a:lstStyle/>
-          <a:p>
-            <a:pPr marL="0" lvl="0" indent="0" algn="ctr" rtl="0">
-              <a:spcBef>
-                <a:spcPts val="0"/>
-              </a:spcBef>
-              <a:spcAft>
-                <a:spcPts val="0"/>
-              </a:spcAft>
-              <a:buNone/>
-            </a:pPr>
-            <a:r>
-              <a:rPr lang="en-GB" sz="800">
-                <a:solidFill>
-                  <a:schemeClr val="dk2"/>
-                </a:solidFill>
-              </a:rPr>
-              <a:t>Page 9</a:t>
-            </a:r>
-            <a:endParaRPr sz="800">
-              <a:solidFill>
-                <a:schemeClr val="dk2"/>
-              </a:solidFill>
-            </a:endParaRPr>
-          </a:p>
-        </p:txBody>
-      </p:sp>
-      <p:sp>
-        <p:nvSpPr>
-          <p:cNvPr id="138" name="Google Shape;138;p21"/>
-          <p:cNvSpPr txBox="1">
-            <a:spLocks noGrp="1"/>
-          </p:cNvSpPr>
-          <p:nvPr>
-            <p:ph type="title"/>
-          </p:nvPr>
-        </p:nvSpPr>
-        <p:spPr>
-          <a:xfrm>
-            <a:off x="46725" y="266100"/>
-            <a:ext cx="8520600" cy="572700"/>
-          </a:xfrm>
-          <a:prstGeom prst="rect">
-            <a:avLst/>
-          </a:prstGeom>
-        </p:spPr>
-        <p:txBody>
-          <a:bodyPr spcFirstLastPara="1" wrap="square" lIns="91425" tIns="91425" rIns="91425" bIns="91425" anchor="t" anchorCtr="0">
-            <a:normAutofit fontScale="90000"/>
-          </a:bodyPr>
-          <a:lstStyle/>
-          <a:p>
-            <a:pPr marL="0" lvl="0" indent="0" algn="l" rtl="0">
-              <a:spcBef>
-                <a:spcPts val="0"/>
-              </a:spcBef>
-              <a:spcAft>
-                <a:spcPts val="0"/>
-              </a:spcAft>
-              <a:buClr>
-                <a:schemeClr val="dk1"/>
-              </a:buClr>
-              <a:buSzPct val="39285"/>
-              <a:buFont typeface="Arial"/>
-              <a:buNone/>
-            </a:pPr>
-            <a:r>
-              <a:rPr lang="en-GB"/>
-              <a:t>VHDL Code Implementations</a:t>
-            </a:r>
-            <a:endParaRPr/>
-          </a:p>
-          <a:p>
-            <a:pPr marL="3657600" lvl="0" indent="457200" algn="l" rtl="0">
-              <a:lnSpc>
-                <a:spcPct val="115000"/>
-              </a:lnSpc>
-              <a:spcBef>
-                <a:spcPts val="0"/>
-              </a:spcBef>
-              <a:spcAft>
-                <a:spcPts val="0"/>
-              </a:spcAft>
-              <a:buNone/>
-            </a:pPr>
-            <a:r>
-              <a:rPr lang="en-GB"/>
-              <a:t>Display_Manager.vhd</a:t>
-            </a:r>
-            <a:endParaRPr/>
-          </a:p>
-          <a:p>
-            <a:pPr marL="0" lvl="0" indent="0" algn="l" rtl="0">
-              <a:spcBef>
-                <a:spcPts val="1200"/>
-              </a:spcBef>
-              <a:spcAft>
-                <a:spcPts val="0"/>
-              </a:spcAft>
-              <a:buNone/>
-            </a:pPr>
-            <a:endParaRPr/>
-          </a:p>
-        </p:txBody>
-      </p:sp>
-      <p:pic>
-        <p:nvPicPr>
-          <p:cNvPr id="139" name="Google Shape;139;p21" title="Display_Manager_1.PNG"/>
-          <p:cNvPicPr preferRelativeResize="0"/>
-          <p:nvPr/>
-        </p:nvPicPr>
-        <p:blipFill>
-          <a:blip r:embed="rId3">
-            <a:alphaModFix/>
-          </a:blip>
-          <a:stretch>
-            <a:fillRect/>
-          </a:stretch>
-        </p:blipFill>
-        <p:spPr>
-          <a:xfrm>
-            <a:off x="325225" y="898550"/>
-            <a:ext cx="3670950" cy="4120074"/>
-          </a:xfrm>
-          <a:prstGeom prst="rect">
-            <a:avLst/>
-          </a:prstGeom>
-          <a:noFill/>
-          <a:ln>
-            <a:noFill/>
-          </a:ln>
-        </p:spPr>
-      </p:pic>
-      <p:pic>
-        <p:nvPicPr>
-          <p:cNvPr id="140" name="Google Shape;140;p21"/>
-          <p:cNvPicPr preferRelativeResize="0"/>
-          <p:nvPr/>
-        </p:nvPicPr>
-        <p:blipFill>
-          <a:blip r:embed="rId4">
-            <a:alphaModFix/>
-          </a:blip>
-          <a:stretch>
-            <a:fillRect/>
-          </a:stretch>
-        </p:blipFill>
-        <p:spPr>
-          <a:xfrm>
-            <a:off x="4284575" y="1794700"/>
-            <a:ext cx="3641450" cy="3147175"/>
           </a:xfrm>
           <a:prstGeom prst="rect">
             <a:avLst/>

</xml_diff>